<commit_message>
Reframe track record slide around run-rate profit and payback
Co-Authored-By: Claude Opus 5.5 <noreply@anthropic.com>
Claude-Session: https://claude.ai/code/session_01BZneVAifSNdK9XeKQimWEA
</commit_message>
<xml_diff>
--- a/docs/business/事業概要_AI_MA部門_営業用.pptx
+++ b/docs/business/事業概要_AI_MA部門_営業用.pptx
@@ -122,20 +122,20 @@
   <p:extLst>
     <p:ext uri="{521415D9-36F7-43E2-AB2F-B90AF26B5E84}">
       <p14:sectionLst xmlns:p14="http://schemas.microsoft.com/office/powerpoint/2010/main">
-        <p14:section name="導入" id="{8cc16937-4b75-3e0c-2a59-77a8b316c57e}">
+        <p14:section name="導入" id="{0c11067a-4e42-2917-400f-b8ee68992000}">
           <p14:sldIdLst>
             <p14:sldId id="256"/>
             <p14:sldId id="257"/>
           </p14:sldIdLst>
         </p14:section>
-        <p14:section name="課題と原点" id="{7a12ed32-44f3-b875-7dde-25c4ca94ba72}">
+        <p14:section name="課題と原点" id="{74aebc8c-c3d7-8212-4c3d-dad31ceb801a}">
           <p14:sldIdLst>
             <p14:sldId id="258"/>
             <p14:sldId id="259"/>
             <p14:sldId id="260"/>
           </p14:sldIdLst>
         </p14:section>
-        <p14:section name="サービス" id="{b62c02f7-c5e5-2db8-98c5-5c0db89f538b}">
+        <p14:section name="サービス" id="{3a073087-b382-6431-9d4d-c53a0ec9e8ef}">
           <p14:sldIdLst>
             <p14:sldId id="261"/>
             <p14:sldId id="262"/>
@@ -146,14 +146,14 @@
             <p14:sldId id="267"/>
           </p14:sldIdLst>
         </p14:section>
-        <p14:section name="事業性" id="{1e763889-9a6e-8764-b00f-397e20741e98}">
+        <p14:section name="事業性" id="{5f2218b9-29a8-c0d1-270a-7e712ec6b54b}">
           <p14:sldIdLst>
             <p14:sldId id="268"/>
             <p14:sldId id="269"/>
             <p14:sldId id="270"/>
           </p14:sldIdLst>
         </p14:section>
-        <p14:section name="まとめ" id="{535e21c4-f10c-cca0-204a-ca9f37e6f2b4}">
+        <p14:section name="まとめ" id="{98409290-5d35-5a33-ff71-6cbaa50e39a6}">
           <p14:sldIdLst>
             <p14:sldId id="271"/>
           </p14:sldIdLst>
@@ -177,7 +177,7 @@
       <c:layout/>
       <c:barChart>
         <c:barDir val="bar"/>
-        <c:grouping val="clustered"/>
+        <c:grouping val="stacked"/>
         <c:varyColors val="0"/>
         <c:ser>
           <c:idx val="0"/>
@@ -195,27 +195,28 @@
           </c:tx>
           <c:spPr>
             <a:solidFill>
-              <a:srgbClr val="E6DCCB"/>
+              <a:srgbClr val="9A8F84"/>
             </a:solidFill>
             <a:effectLst/>
           </c:spPr>
           <c:invertIfNegative val="0"/>
           <c:dLbls>
-            <c:numFmt formatCode="0.0&quot;億&quot;" sourceLinked="0"/>
+            <c:numFmt formatCode="0.0;;;" sourceLinked="0"/>
             <c:txPr>
               <a:bodyPr/>
               <a:lstStyle/>
               <a:p>
                 <a:pPr>
-                  <a:defRPr b="0" i="0" strike="noStrike" sz="1000" u="none">
+                  <a:defRPr b="0" i="0" strike="noStrike" sz="900" u="none">
                     <a:solidFill>
-                      <a:srgbClr val="2B2622"/>
+                      <a:srgbClr val="FFFFFF"/>
                     </a:solidFill>
                     <a:latin typeface="+mn-lt"/>
                   </a:defRPr>
                 </a:pPr>
               </a:p>
             </c:txPr>
+            <c:dLblPos val="ctr"/>
             <c:showLegendKey val="0"/>
             <c:showVal val="1"/>
             <c:showCatName val="0"/>
@@ -226,15 +227,21 @@
           </c:dLbls>
           <c:cat>
             <c:multiLvlStrRef>
-              <c:f>Sheet1!$A$2:$A$3</c:f>
+              <c:f>Sheet1!$A$2:$A$5</c:f>
               <c:multiLvlStrCache>
-                <c:ptCount val="2"/>
+                <c:ptCount val="4"/>
                 <c:lvl>
                   <c:pt idx="0">
-                    <c:v>第1期 2011–19</c:v>
+                    <c:v>第1期 投じた額</c:v>
                   </c:pt>
                   <c:pt idx="1">
-                    <c:v>第2期 2020–</c:v>
+                    <c:v>第1期 戻った額</c:v>
+                  </c:pt>
+                  <c:pt idx="2">
+                    <c:v>第2期 投じた額</c:v>
+                  </c:pt>
+                  <c:pt idx="3">
+                    <c:v>第2期 得た資産＋1年分の利益</c:v>
                   </c:pt>
                 </c:lvl>
               </c:multiLvlStrCache>
@@ -242,15 +249,21 @@
           </c:cat>
           <c:val>
             <c:numRef>
-              <c:f>Sheet1!$B$2:$B$3</c:f>
+              <c:f>Sheet1!$B$2:$B$5</c:f>
               <c:numCache>
                 <c:formatCode>General</c:formatCode>
-                <c:ptCount val="2"/>
+                <c:ptCount val="4"/>
                 <c:pt idx="0">
                   <c:v>10.8</c:v>
                 </c:pt>
                 <c:pt idx="1">
+                  <c:v>0</c:v>
+                </c:pt>
+                <c:pt idx="2">
                   <c:v>14.4</c:v>
+                </c:pt>
+                <c:pt idx="3">
+                  <c:v>0</c:v>
                 </c:pt>
               </c:numCache>
             </c:numRef>
@@ -265,7 +278,187 @@
               <c:strCache>
                 <c:ptCount val="1"/>
                 <c:pt idx="0">
-                  <c:v>回収＋事業利益／取得純資産</c:v>
+                  <c:v>営業利益</c:v>
+                </c:pt>
+              </c:strCache>
+            </c:strRef>
+          </c:tx>
+          <c:spPr>
+            <a:solidFill>
+              <a:srgbClr val="2B2622"/>
+            </a:solidFill>
+            <a:effectLst/>
+          </c:spPr>
+          <c:invertIfNegative val="0"/>
+          <c:dLbls>
+            <c:numFmt formatCode="0.0;;;" sourceLinked="0"/>
+            <c:txPr>
+              <a:bodyPr/>
+              <a:lstStyle/>
+              <a:p>
+                <a:pPr>
+                  <a:defRPr b="0" i="0" strike="noStrike" sz="900" u="none">
+                    <a:solidFill>
+                      <a:srgbClr val="FFFFFF"/>
+                    </a:solidFill>
+                    <a:latin typeface="+mn-lt"/>
+                  </a:defRPr>
+                </a:pPr>
+              </a:p>
+            </c:txPr>
+            <c:dLblPos val="ctr"/>
+            <c:showLegendKey val="0"/>
+            <c:showVal val="1"/>
+            <c:showCatName val="0"/>
+            <c:showSerName val="0"/>
+            <c:showPercent val="0"/>
+            <c:showBubbleSize val="0"/>
+            <c:showLeaderLines val="0"/>
+          </c:dLbls>
+          <c:cat>
+            <c:multiLvlStrRef>
+              <c:f>Sheet1!$A$2:$A$5</c:f>
+              <c:multiLvlStrCache>
+                <c:ptCount val="4"/>
+                <c:lvl>
+                  <c:pt idx="0">
+                    <c:v>第1期 投じた額</c:v>
+                  </c:pt>
+                  <c:pt idx="1">
+                    <c:v>第1期 戻った額</c:v>
+                  </c:pt>
+                  <c:pt idx="2">
+                    <c:v>第2期 投じた額</c:v>
+                  </c:pt>
+                  <c:pt idx="3">
+                    <c:v>第2期 得た資産＋1年分の利益</c:v>
+                  </c:pt>
+                </c:lvl>
+              </c:multiLvlStrCache>
+            </c:multiLvlStrRef>
+          </c:cat>
+          <c:val>
+            <c:numRef>
+              <c:f>Sheet1!$C$2:$C$5</c:f>
+              <c:numCache>
+                <c:formatCode>General</c:formatCode>
+                <c:ptCount val="4"/>
+                <c:pt idx="0">
+                  <c:v>0</c:v>
+                </c:pt>
+                <c:pt idx="1">
+                  <c:v>7.6</c:v>
+                </c:pt>
+                <c:pt idx="2">
+                  <c:v>0</c:v>
+                </c:pt>
+                <c:pt idx="3">
+                  <c:v>2.4</c:v>
+                </c:pt>
+              </c:numCache>
+            </c:numRef>
+          </c:val>
+        </c:ser>
+        <c:ser>
+          <c:idx val="2"/>
+          <c:order val="2"/>
+          <c:tx>
+            <c:strRef>
+              <c:f>Sheet1!$D$1</c:f>
+              <c:strCache>
+                <c:ptCount val="1"/>
+                <c:pt idx="0">
+                  <c:v>売却回収</c:v>
+                </c:pt>
+              </c:strCache>
+            </c:strRef>
+          </c:tx>
+          <c:spPr>
+            <a:solidFill>
+              <a:srgbClr val="C9AE7E"/>
+            </a:solidFill>
+            <a:effectLst/>
+          </c:spPr>
+          <c:invertIfNegative val="0"/>
+          <c:dLbls>
+            <c:numFmt formatCode="0.0;;;" sourceLinked="0"/>
+            <c:txPr>
+              <a:bodyPr/>
+              <a:lstStyle/>
+              <a:p>
+                <a:pPr>
+                  <a:defRPr b="0" i="0" strike="noStrike" sz="900" u="none">
+                    <a:solidFill>
+                      <a:srgbClr val="FFFFFF"/>
+                    </a:solidFill>
+                    <a:latin typeface="+mn-lt"/>
+                  </a:defRPr>
+                </a:pPr>
+              </a:p>
+            </c:txPr>
+            <c:dLblPos val="ctr"/>
+            <c:showLegendKey val="0"/>
+            <c:showVal val="1"/>
+            <c:showCatName val="0"/>
+            <c:showSerName val="0"/>
+            <c:showPercent val="0"/>
+            <c:showBubbleSize val="0"/>
+            <c:showLeaderLines val="0"/>
+          </c:dLbls>
+          <c:cat>
+            <c:multiLvlStrRef>
+              <c:f>Sheet1!$A$2:$A$5</c:f>
+              <c:multiLvlStrCache>
+                <c:ptCount val="4"/>
+                <c:lvl>
+                  <c:pt idx="0">
+                    <c:v>第1期 投じた額</c:v>
+                  </c:pt>
+                  <c:pt idx="1">
+                    <c:v>第1期 戻った額</c:v>
+                  </c:pt>
+                  <c:pt idx="2">
+                    <c:v>第2期 投じた額</c:v>
+                  </c:pt>
+                  <c:pt idx="3">
+                    <c:v>第2期 得た資産＋1年分の利益</c:v>
+                  </c:pt>
+                </c:lvl>
+              </c:multiLvlStrCache>
+            </c:multiLvlStrRef>
+          </c:cat>
+          <c:val>
+            <c:numRef>
+              <c:f>Sheet1!$D$2:$D$5</c:f>
+              <c:numCache>
+                <c:formatCode>General</c:formatCode>
+                <c:ptCount val="4"/>
+                <c:pt idx="0">
+                  <c:v>0</c:v>
+                </c:pt>
+                <c:pt idx="1">
+                  <c:v>5.3</c:v>
+                </c:pt>
+                <c:pt idx="2">
+                  <c:v>0</c:v>
+                </c:pt>
+                <c:pt idx="3">
+                  <c:v>0</c:v>
+                </c:pt>
+              </c:numCache>
+            </c:numRef>
+          </c:val>
+        </c:ser>
+        <c:ser>
+          <c:idx val="3"/>
+          <c:order val="3"/>
+          <c:tx>
+            <c:strRef>
+              <c:f>Sheet1!$E$1</c:f>
+              <c:strCache>
+                <c:ptCount val="1"/>
+                <c:pt idx="0">
+                  <c:v>手元の純資産</c:v>
                 </c:pt>
               </c:strCache>
             </c:strRef>
@@ -278,21 +471,22 @@
           </c:spPr>
           <c:invertIfNegative val="0"/>
           <c:dLbls>
-            <c:numFmt formatCode="0.0&quot;億&quot;" sourceLinked="0"/>
+            <c:numFmt formatCode="0.0;;;" sourceLinked="0"/>
             <c:txPr>
               <a:bodyPr/>
               <a:lstStyle/>
               <a:p>
                 <a:pPr>
-                  <a:defRPr b="0" i="0" strike="noStrike" sz="1000" u="none">
+                  <a:defRPr b="0" i="0" strike="noStrike" sz="900" u="none">
                     <a:solidFill>
-                      <a:srgbClr val="2B2622"/>
+                      <a:srgbClr val="FFFFFF"/>
                     </a:solidFill>
                     <a:latin typeface="+mn-lt"/>
                   </a:defRPr>
                 </a:pPr>
               </a:p>
             </c:txPr>
+            <c:dLblPos val="ctr"/>
             <c:showLegendKey val="0"/>
             <c:showVal val="1"/>
             <c:showCatName val="0"/>
@@ -303,15 +497,21 @@
           </c:dLbls>
           <c:cat>
             <c:multiLvlStrRef>
-              <c:f>Sheet1!$A$2:$A$3</c:f>
+              <c:f>Sheet1!$A$2:$A$5</c:f>
               <c:multiLvlStrCache>
-                <c:ptCount val="2"/>
+                <c:ptCount val="4"/>
                 <c:lvl>
                   <c:pt idx="0">
-                    <c:v>第1期 2011–19</c:v>
+                    <c:v>第1期 投じた額</c:v>
                   </c:pt>
                   <c:pt idx="1">
-                    <c:v>第2期 2020–</c:v>
+                    <c:v>第1期 戻った額</c:v>
+                  </c:pt>
+                  <c:pt idx="2">
+                    <c:v>第2期 投じた額</c:v>
+                  </c:pt>
+                  <c:pt idx="3">
+                    <c:v>第2期 得た資産＋1年分の利益</c:v>
                   </c:pt>
                 </c:lvl>
               </c:multiLvlStrCache>
@@ -319,14 +519,20 @@
           </c:cat>
           <c:val>
             <c:numRef>
-              <c:f>Sheet1!$C$2:$C$3</c:f>
+              <c:f>Sheet1!$E$2:$E$5</c:f>
               <c:numCache>
                 <c:formatCode>General</c:formatCode>
-                <c:ptCount val="2"/>
+                <c:ptCount val="4"/>
                 <c:pt idx="0">
-                  <c:v>9.4</c:v>
+                  <c:v>0</c:v>
                 </c:pt>
                 <c:pt idx="1">
+                  <c:v>2</c:v>
+                </c:pt>
+                <c:pt idx="2">
+                  <c:v>0</c:v>
+                </c:pt>
+                <c:pt idx="3">
                   <c:v>15.9</c:v>
                 </c:pt>
               </c:numCache>
@@ -334,21 +540,22 @@
           </c:val>
         </c:ser>
         <c:dLbls>
-          <c:numFmt formatCode="0.0&quot;億&quot;" sourceLinked="0"/>
+          <c:numFmt formatCode="0.0;;;" sourceLinked="0"/>
           <c:txPr>
             <a:bodyPr/>
             <a:lstStyle/>
             <a:p>
               <a:pPr>
-                <a:defRPr b="0" i="0" strike="noStrike" sz="1000" u="none">
+                <a:defRPr b="0" i="0" strike="noStrike" sz="900" u="none">
                   <a:solidFill>
-                    <a:srgbClr val="2B2622"/>
+                    <a:srgbClr val="FFFFFF"/>
                   </a:solidFill>
                   <a:latin typeface="+mn-lt"/>
                 </a:defRPr>
               </a:pPr>
             </a:p>
           </c:txPr>
+          <c:dLblPos val="ctr"/>
           <c:showLegendKey val="0"/>
           <c:showVal val="1"/>
           <c:showCatName val="0"/>
@@ -357,8 +564,8 @@
           <c:showBubbleSize val="0"/>
           <c:showLeaderLines val="0"/>
         </c:dLbls>
-        <c:gapWidth val="45"/>
-        <c:overlap val="0"/>
+        <c:gapWidth val="35"/>
+        <c:overlap val="100"/>
         <c:axId val="2094734554"/>
         <c:axId val="2094734552"/>
         <c:axId val="2094734556"/>
@@ -366,7 +573,7 @@
       <c:catAx>
         <c:axId val="2094734554"/>
         <c:scaling>
-          <c:orientation val="minMax"/>
+          <c:orientation val="maxMin"/>
         </c:scaling>
         <c:delete val="0"/>
         <c:axPos val="l"/>
@@ -376,7 +583,9 @@
         <c:tickLblPos val="nextTo"/>
         <c:spPr>
           <a:ln w="12700" cap="flat">
-            <a:noFill/>
+            <a:solidFill>
+              <a:srgbClr val="888888"/>
+            </a:solidFill>
             <a:prstDash val="solid"/>
             <a:round/>
           </a:ln>
@@ -386,7 +595,7 @@
           <a:lstStyle/>
           <a:p>
             <a:pPr>
-              <a:defRPr sz="1000" b="0" i="0" u="none" strike="noStrike">
+              <a:defRPr sz="900" b="0" i="0" u="none" strike="noStrike">
                 <a:solidFill>
                   <a:srgbClr val="2B2622"/>
                 </a:solidFill>
@@ -450,7 +659,7 @@
       </c:spPr>
     </c:plotArea>
     <c:legend>
-      <c:legendPos val="b"/>
+      <c:legendPos val="r"/>
       <c:overlay val="0"/>
       <c:txPr>
         <a:bodyPr/>
@@ -2223,7 +2432,7 @@
           <a:p>
             <a:r>
               <a:rPr lang="en-US" dirty="0"/>
-              <a:t>負けた前半も隠さない。値づけのルールを変えたら、後半は買った瞬間に勝てるようになった。このルールがサービスの中身です。</a:t>
+              <a:t>第1期は投じた10.8億が14.9億で戻った。第2期は純資産より安く買えているので、買った瞬間に資産で元が取れていて、そのうえ毎年2.4億の営業利益が乗る。約6年で買収額を利益だけで回収できる計算。</a:t>
             </a:r>
             <a:endParaRPr lang="en-US" dirty="0"/>
           </a:p>
@@ -14076,7 +14285,7 @@
                   <a:schemeClr val="tx1"/>
                 </a:solidFill>
               </a:rPr>
-              <a:t>49戦の実績：勝ちも負けも、すべて自社の実案件</a:t>
+              <a:t>49戦の実績：安く買い、利益と資産で回収する</a:t>
             </a:r>
             <a:endParaRPr lang="en-US" sz="3000" dirty="0"/>
           </a:p>
@@ -14114,7 +14323,7 @@
                   <a:schemeClr val="accent2"/>
                 </a:solidFill>
               </a:rPr>
-              <a:t>2011年3月〜現在。仲介ではなく、自分のお金で買い、売り、立て直してきた</a:t>
+              <a:t>買収額を「いくらの利益と資産が手に入ったか」で測る。2011年3月〜現在、すべて自社の実案件</a:t>
             </a:r>
             <a:endParaRPr lang="en-US" sz="1350" dirty="0"/>
           </a:p>
@@ -14122,18 +14331,18 @@
       </p:sp>
       <p:sp>
         <p:nvSpPr>
-          <p:cNvPr id="6" name="stat 買収28／売却21／出資2"/>
+          <p:cNvPr id="6" name="stat 買収28／売却21／出資2。発掘はほぼ自分"/>
           <p:cNvSpPr/>
           <p:nvPr/>
         </p:nvSpPr>
         <p:spPr>
           <a:xfrm>
             <a:off x="685800" y="2011680"/>
-            <a:ext cx="2560320" cy="2011680"/>
+            <a:ext cx="2560320" cy="1901952"/>
           </a:xfrm>
           <a:prstGeom prst="roundRect">
             <a:avLst>
-              <a:gd name="adj" fmla="val 2727"/>
+              <a:gd name="adj" fmla="val 2885"/>
             </a:avLst>
           </a:prstGeom>
           <a:solidFill>
@@ -14260,7 +14469,7 @@
         <p:spPr>
           <a:xfrm>
             <a:off x="923544" y="3502152"/>
-            <a:ext cx="2103120" cy="411480"/>
+            <a:ext cx="2103120" cy="301752"/>
           </a:xfrm>
           <a:prstGeom prst="rect">
             <a:avLst/>
@@ -14281,7 +14490,7 @@
                   <a:schemeClr val="accent2"/>
                 </a:solidFill>
               </a:rPr>
-              <a:t>買収28／売却21／出資2</a:t>
+              <a:t>買収28／売却21／出資2。発掘はほぼ自分</a:t>
             </a:r>
             <a:endParaRPr lang="en-US" sz="1050" dirty="0"/>
           </a:p>
@@ -14289,18 +14498,18 @@
       </p:sp>
       <p:sp>
         <p:nvSpPr>
-          <p:cNvPr id="11" name="stat 支払った買収総額（回収16.7億円）"/>
+          <p:cNvPr id="11" name="stat 第1期の回収倍率。投じた10.8億円が14.9億円で戻った"/>
           <p:cNvSpPr/>
           <p:nvPr/>
         </p:nvSpPr>
         <p:spPr>
           <a:xfrm>
             <a:off x="3456432" y="2011680"/>
-            <a:ext cx="2560320" cy="2011680"/>
+            <a:ext cx="2560320" cy="1901952"/>
           </a:xfrm>
           <a:prstGeom prst="roundRect">
             <a:avLst>
-              <a:gd name="adj" fmla="val 2727"/>
+              <a:gd name="adj" fmla="val 2885"/>
             </a:avLst>
           </a:prstGeom>
           <a:solidFill>
@@ -14376,7 +14585,7 @@
                   <a:schemeClr val="accent1"/>
                 </a:solidFill>
               </a:rPr>
-              <a:t>25.2</a:t>
+              <a:t>1.4</a:t>
             </a:r>
             <a:endParaRPr lang="en-US" sz="3600" dirty="0"/>
           </a:p>
@@ -14412,7 +14621,7 @@
                   <a:schemeClr val="tx1"/>
                 </a:solidFill>
               </a:rPr>
-              <a:t>億円</a:t>
+              <a:t>倍</a:t>
             </a:r>
             <a:endParaRPr lang="en-US" sz="1300" dirty="0"/>
           </a:p>
@@ -14427,7 +14636,7 @@
         <p:spPr>
           <a:xfrm>
             <a:off x="3694176" y="3502152"/>
-            <a:ext cx="2103120" cy="411480"/>
+            <a:ext cx="2103120" cy="301752"/>
           </a:xfrm>
           <a:prstGeom prst="rect">
             <a:avLst/>
@@ -14448,7 +14657,7 @@
                   <a:schemeClr val="accent2"/>
                 </a:solidFill>
               </a:rPr>
-              <a:t>支払った買収総額（回収16.7億円）</a:t>
+              <a:t>第1期の回収倍率。投じた10.8億円が14.9億円で戻った</a:t>
             </a:r>
             <a:endParaRPr lang="en-US" sz="1050" dirty="0"/>
           </a:p>
@@ -14456,18 +14665,18 @@
       </p:sp>
       <p:sp>
         <p:nvSpPr>
-          <p:cNvPr id="16" name="stat 売上74億円分の事業を25.2億円で取得"/>
+          <p:cNvPr id="16" name="stat 第2期の買収先の営業利益（ランレート、2026年予想）"/>
           <p:cNvSpPr/>
           <p:nvPr/>
         </p:nvSpPr>
         <p:spPr>
           <a:xfrm>
             <a:off x="6227064" y="2011680"/>
-            <a:ext cx="2560320" cy="2011680"/>
+            <a:ext cx="2560320" cy="1901952"/>
           </a:xfrm>
           <a:prstGeom prst="roundRect">
             <a:avLst>
-              <a:gd name="adj" fmla="val 2727"/>
+              <a:gd name="adj" fmla="val 2885"/>
             </a:avLst>
           </a:prstGeom>
           <a:solidFill>
@@ -14543,7 +14752,7 @@
                   <a:schemeClr val="accent1"/>
                 </a:solidFill>
               </a:rPr>
-              <a:t>0.34</a:t>
+              <a:t>2.4</a:t>
             </a:r>
             <a:endParaRPr lang="en-US" sz="3600" dirty="0"/>
           </a:p>
@@ -14579,7 +14788,7 @@
                   <a:schemeClr val="tx1"/>
                 </a:solidFill>
               </a:rPr>
-              <a:t>倍</a:t>
+              <a:t>億円／年</a:t>
             </a:r>
             <a:endParaRPr lang="en-US" sz="1300" dirty="0"/>
           </a:p>
@@ -14594,7 +14803,7 @@
         <p:spPr>
           <a:xfrm>
             <a:off x="6464808" y="3502152"/>
-            <a:ext cx="2103120" cy="411480"/>
+            <a:ext cx="2103120" cy="301752"/>
           </a:xfrm>
           <a:prstGeom prst="rect">
             <a:avLst/>
@@ -14615,7 +14824,7 @@
                   <a:schemeClr val="accent2"/>
                 </a:solidFill>
               </a:rPr>
-              <a:t>売上74億円分の事業を25.2億円で取得</a:t>
+              <a:t>第2期の買収先の営業利益（ランレート、2026年予想）</a:t>
             </a:r>
             <a:endParaRPr lang="en-US" sz="1050" dirty="0"/>
           </a:p>
@@ -14623,18 +14832,18 @@
       </p:sp>
       <p:sp>
         <p:nvSpPr>
-          <p:cNvPr id="21" name="stat グループ売上 23億円→66億円（2019→2026予想）"/>
+          <p:cNvPr id="21" name="stat 第2期の回収年数（買収額14.4億円÷年間営業利益）"/>
           <p:cNvSpPr/>
           <p:nvPr/>
         </p:nvSpPr>
         <p:spPr>
           <a:xfrm>
             <a:off x="8997696" y="2011680"/>
-            <a:ext cx="2560320" cy="2011680"/>
+            <a:ext cx="2560320" cy="1901952"/>
           </a:xfrm>
           <a:prstGeom prst="roundRect">
             <a:avLst>
-              <a:gd name="adj" fmla="val 2727"/>
+              <a:gd name="adj" fmla="val 2885"/>
             </a:avLst>
           </a:prstGeom>
           <a:solidFill>
@@ -14710,7 +14919,7 @@
                   <a:schemeClr val="accent1"/>
                 </a:solidFill>
               </a:rPr>
-              <a:t>2.9</a:t>
+              <a:t>約6</a:t>
             </a:r>
             <a:endParaRPr lang="en-US" sz="3600" dirty="0"/>
           </a:p>
@@ -14746,7 +14955,7 @@
                   <a:schemeClr val="tx1"/>
                 </a:solidFill>
               </a:rPr>
-              <a:t>倍</a:t>
+              <a:t>年</a:t>
             </a:r>
             <a:endParaRPr lang="en-US" sz="1300" dirty="0"/>
           </a:p>
@@ -14761,7 +14970,7 @@
         <p:spPr>
           <a:xfrm>
             <a:off x="9235440" y="3502152"/>
-            <a:ext cx="2103120" cy="411480"/>
+            <a:ext cx="2103120" cy="301752"/>
           </a:xfrm>
           <a:prstGeom prst="rect">
             <a:avLst/>
@@ -14782,7 +14991,7 @@
                   <a:schemeClr val="accent2"/>
                 </a:solidFill>
               </a:rPr>
-              <a:t>グループ売上 23億円→66億円（2019→2026予想）</a:t>
+              <a:t>第2期の回収年数（買収額14.4億円÷年間営業利益）</a:t>
             </a:r>
             <a:endParaRPr lang="en-US" sz="1050" dirty="0"/>
           </a:p>
@@ -14790,13 +14999,13 @@
       </p:sp>
       <p:graphicFrame>
         <p:nvGraphicFramePr>
-          <p:cNvPr id="26" name="two phase chart" descr=""/>
+          <p:cNvPr id="26" name="invest vs return chart" descr=""/>
           <p:cNvGraphicFramePr/>
           <p:nvPr/>
         </p:nvGraphicFramePr>
         <p:xfrm>
-          <a:off x="685800" y="4160520"/>
-          <a:ext cx="6035040" cy="1965960"/>
+          <a:off x="685800" y="4023360"/>
+          <a:ext cx="6400800" cy="2011680"/>
         </p:xfrm>
         <a:graphic xmlns:a="http://schemas.openxmlformats.org/drawingml/2006/main">
           <a:graphicData uri="http://schemas.openxmlformats.org/drawingml/2006/chart">
@@ -14812,12 +15021,12 @@
         </p:nvSpPr>
         <p:spPr>
           <a:xfrm>
-            <a:off x="6949440" y="4114800"/>
-            <a:ext cx="4553712" cy="896112"/>
+            <a:off x="7315200" y="4041648"/>
+            <a:ext cx="4187952" cy="932688"/>
           </a:xfrm>
           <a:prstGeom prst="roundRect">
             <a:avLst>
-              <a:gd name="adj" fmla="val 6122"/>
+              <a:gd name="adj" fmla="val 5882"/>
             </a:avLst>
           </a:prstGeom>
           <a:solidFill>
@@ -14846,8 +15055,8 @@
         </p:nvSpPr>
         <p:spPr>
           <a:xfrm>
-            <a:off x="7178040" y="4114800"/>
-            <a:ext cx="4114800" cy="896112"/>
+            <a:off x="7498080" y="4041648"/>
+            <a:ext cx="3840480" cy="932688"/>
           </a:xfrm>
           <a:prstGeom prst="rect">
             <a:avLst/>
@@ -14868,18 +15077,21 @@
                   <a:schemeClr val="accent2"/>
                 </a:solidFill>
               </a:rPr>
-              <a:t>第1期：授業料を払った　</a:t>
-            </a:r>
+              <a:t>第1期 2011–19：数で獲りにいった</a:t>
+            </a:r>
+            <a:endParaRPr lang="en-US" sz="1200" dirty="0"/>
+          </a:p>
+          <a:p>
             <a:pPr indent="0" marL="0">
               <a:buNone/>
             </a:pPr>
             <a:r>
-              <a:rPr lang="en-US" sz="1200" dirty="0">
+              <a:rPr lang="en-US" sz="1050" dirty="0">
                 <a:solidFill>
                   <a:schemeClr val="tx1"/>
                 </a:solidFill>
               </a:rPr>
-              <a:t>10.8億円を投じ、回収と利益で9.4億円。前半は赤字</a:t>
+              <a:t>売上の0.25倍で買い、保有中の営業利益7.6億＋売却5.3億＋純資産2.0億で回収</a:t>
             </a:r>
             <a:endParaRPr lang="en-US" sz="1200" dirty="0"/>
           </a:p>
@@ -14893,12 +15105,12 @@
         </p:nvSpPr>
         <p:spPr>
           <a:xfrm>
-            <a:off x="6949440" y="5138928"/>
-            <a:ext cx="4553712" cy="896112"/>
+            <a:off x="7315200" y="5084064"/>
+            <a:ext cx="4187952" cy="932688"/>
           </a:xfrm>
           <a:prstGeom prst="roundRect">
             <a:avLst>
-              <a:gd name="adj" fmla="val 6122"/>
+              <a:gd name="adj" fmla="val 5882"/>
             </a:avLst>
           </a:prstGeom>
           <a:solidFill>
@@ -14927,8 +15139,8 @@
         </p:nvSpPr>
         <p:spPr>
           <a:xfrm>
-            <a:off x="7178040" y="5138928"/>
-            <a:ext cx="4114800" cy="896112"/>
+            <a:off x="7498080" y="5084064"/>
+            <a:ext cx="3840480" cy="932688"/>
           </a:xfrm>
           <a:prstGeom prst="rect">
             <a:avLst/>
@@ -14949,18 +15161,21 @@
                   <a:schemeClr val="accent1"/>
                 </a:solidFill>
               </a:rPr>
-              <a:t>第2期：買った瞬間に勝つ　</a:t>
-            </a:r>
+              <a:t>第2期 2020–：純資産より安く買う</a:t>
+            </a:r>
+            <a:endParaRPr lang="en-US" sz="1200" dirty="0"/>
+          </a:p>
+          <a:p>
             <a:pPr indent="0" marL="0">
               <a:buNone/>
             </a:pPr>
             <a:r>
-              <a:rPr lang="en-US" sz="1200" dirty="0">
+              <a:rPr lang="en-US" sz="1050" dirty="0">
                 <a:solidFill>
                   <a:schemeClr val="tx1"/>
                 </a:solidFill>
               </a:rPr>
-              <a:t>14.4億円で純資産15.9億円を取得。値づけを変えただけで反転</a:t>
+              <a:t>純資産の9割の価格で取得し、毎年2.4億円の営業利益が上乗せされていく</a:t>
             </a:r>
             <a:endParaRPr lang="en-US" sz="1200" dirty="0"/>
           </a:p>
@@ -14996,7 +15211,7 @@
                   <a:schemeClr val="accent5"/>
                 </a:solidFill>
               </a:rPr>
-              <a:t>出典：中野邦人 M&amp;A勝敗一覧表、グループ売上管理表（自社実データ）</a:t>
+              <a:t>単位：億円。第1期の営業利益は保有期間中の累計。第2期のランレートはM&amp;Aで取得したグループ会社の2026年予想営業利益。出典：中野邦人 M&amp;A勝敗一覧表、グループ売上管理表</a:t>
             </a:r>
             <a:endParaRPr lang="en-US" sz="900" dirty="0"/>
           </a:p>

</xml_diff>

<commit_message>
Show current operating profit of key acquisitions on track record slide
Co-Authored-By: Claude Opus 5.5 <noreply@anthropic.com>
Claude-Session: https://claude.ai/code/session_01BZneVAifSNdK9XeKQimWEA
</commit_message>
<xml_diff>
--- a/docs/business/事業概要_AI_MA部門_営業用.pptx
+++ b/docs/business/事業概要_AI_MA部門_営業用.pptx
@@ -122,20 +122,20 @@
   <p:extLst>
     <p:ext uri="{521415D9-36F7-43E2-AB2F-B90AF26B5E84}">
       <p14:sectionLst xmlns:p14="http://schemas.microsoft.com/office/powerpoint/2010/main">
-        <p14:section name="導入" id="{0c11067a-4e42-2917-400f-b8ee68992000}">
+        <p14:section name="導入" id="{99787ca1-49af-a0d0-493f-4a616528ca5c}">
           <p14:sldIdLst>
             <p14:sldId id="256"/>
             <p14:sldId id="257"/>
           </p14:sldIdLst>
         </p14:section>
-        <p14:section name="課題と原点" id="{74aebc8c-c3d7-8212-4c3d-dad31ceb801a}">
+        <p14:section name="課題と原点" id="{10529317-3af5-e863-f7a8-f85d72b9073e}">
           <p14:sldIdLst>
             <p14:sldId id="258"/>
             <p14:sldId id="259"/>
             <p14:sldId id="260"/>
           </p14:sldIdLst>
         </p14:section>
-        <p14:section name="サービス" id="{3a073087-b382-6431-9d4d-c53a0ec9e8ef}">
+        <p14:section name="サービス" id="{5e69687d-b065-9cfb-28c0-19e10453e5f3}">
           <p14:sldIdLst>
             <p14:sldId id="261"/>
             <p14:sldId id="262"/>
@@ -146,14 +146,14 @@
             <p14:sldId id="267"/>
           </p14:sldIdLst>
         </p14:section>
-        <p14:section name="事業性" id="{5f2218b9-29a8-c0d1-270a-7e712ec6b54b}">
+        <p14:section name="事業性" id="{2be83fbb-b942-16dc-8848-40aa20647929}">
           <p14:sldIdLst>
             <p14:sldId id="268"/>
             <p14:sldId id="269"/>
             <p14:sldId id="270"/>
           </p14:sldIdLst>
         </p14:section>
-        <p14:section name="まとめ" id="{98409290-5d35-5a33-ff71-6cbaa50e39a6}">
+        <p14:section name="まとめ" id="{219c0a43-d18b-1fba-5c6d-7042dde40b4f}">
           <p14:sldIdLst>
             <p14:sldId id="271"/>
           </p14:sldIdLst>
@@ -2432,7 +2432,7 @@
           <a:p>
             <a:r>
               <a:rPr lang="en-US" dirty="0"/>
-              <a:t>第1期は投じた10.8億が14.9億で戻った。第2期は純資産より安く買えているので、買った瞬間に資産で元が取れていて、そのうえ毎年2.4億の営業利益が乗る。約6年で買収額を利益だけで回収できる計算。</a:t>
+              <a:t>第1期は投じた10.8億が14.9億で戻った。第2期は純資産より安く買っているので、買った瞬間に資産で元が取れている。飲食A社は8.2億で買って今期の営業利益1.3億、飲食B事業は1,400万で買って今期8,000万。この2件だけで年2.1億、約4年で買収額を利益で回収できる。</a:t>
             </a:r>
             <a:endParaRPr lang="en-US" dirty="0"/>
           </a:p>
@@ -14331,7 +14331,7 @@
       </p:sp>
       <p:sp>
         <p:nvSpPr>
-          <p:cNvPr id="6" name="stat 買収28／売却21／出資2。発掘はほぼ自分"/>
+          <p:cNvPr id="6" name="stat 第1期の回収倍率。投じた10.8億円が14.9億円で戻った"/>
           <p:cNvSpPr/>
           <p:nvPr/>
         </p:nvSpPr>
@@ -14418,7 +14418,7 @@
                   <a:schemeClr val="accent1"/>
                 </a:solidFill>
               </a:rPr>
-              <a:t>約50</a:t>
+              <a:t>1.4</a:t>
             </a:r>
             <a:endParaRPr lang="en-US" sz="3600" dirty="0"/>
           </a:p>
@@ -14454,7 +14454,7 @@
                   <a:schemeClr val="tx1"/>
                 </a:solidFill>
               </a:rPr>
-              <a:t>案件</a:t>
+              <a:t>倍</a:t>
             </a:r>
             <a:endParaRPr lang="en-US" sz="1300" dirty="0"/>
           </a:p>
@@ -14490,7 +14490,7 @@
                   <a:schemeClr val="accent2"/>
                 </a:solidFill>
               </a:rPr>
-              <a:t>買収28／売却21／出資2。発掘はほぼ自分</a:t>
+              <a:t>第1期の回収倍率。投じた10.8億円が14.9億円で戻った</a:t>
             </a:r>
             <a:endParaRPr lang="en-US" sz="1050" dirty="0"/>
           </a:p>
@@ -14498,7 +14498,7 @@
       </p:sp>
       <p:sp>
         <p:nvSpPr>
-          <p:cNvPr id="11" name="stat 第1期の回収倍率。投じた10.8億円が14.9億円で戻った"/>
+          <p:cNvPr id="11" name="stat 第2期の純資産倍率。14.4億円で純資産15.9億円を取得"/>
           <p:cNvSpPr/>
           <p:nvPr/>
         </p:nvSpPr>
@@ -14585,7 +14585,7 @@
                   <a:schemeClr val="accent1"/>
                 </a:solidFill>
               </a:rPr>
-              <a:t>1.4</a:t>
+              <a:t>0.9</a:t>
             </a:r>
             <a:endParaRPr lang="en-US" sz="3600" dirty="0"/>
           </a:p>
@@ -14657,7 +14657,7 @@
                   <a:schemeClr val="accent2"/>
                 </a:solidFill>
               </a:rPr>
-              <a:t>第1期の回収倍率。投じた10.8億円が14.9億円で戻った</a:t>
+              <a:t>第2期の純資産倍率。14.4億円で純資産15.9億円を取得</a:t>
             </a:r>
             <a:endParaRPr lang="en-US" sz="1050" dirty="0"/>
           </a:p>
@@ -14665,7 +14665,7 @@
       </p:sp>
       <p:sp>
         <p:nvSpPr>
-          <p:cNvPr id="16" name="stat 第2期の買収先の営業利益（ランレート、2026年予想）"/>
+          <p:cNvPr id="16" name="stat 飲食A社の今期営業利益。8.2億円で取得、純資産13.0億円"/>
           <p:cNvSpPr/>
           <p:nvPr/>
         </p:nvSpPr>
@@ -14752,7 +14752,7 @@
                   <a:schemeClr val="accent1"/>
                 </a:solidFill>
               </a:rPr>
-              <a:t>2.4</a:t>
+              <a:t>1.3億</a:t>
             </a:r>
             <a:endParaRPr lang="en-US" sz="3600" dirty="0"/>
           </a:p>
@@ -14788,7 +14788,7 @@
                   <a:schemeClr val="tx1"/>
                 </a:solidFill>
               </a:rPr>
-              <a:t>億円／年</a:t>
+              <a:t>円／年</a:t>
             </a:r>
             <a:endParaRPr lang="en-US" sz="1300" dirty="0"/>
           </a:p>
@@ -14824,7 +14824,7 @@
                   <a:schemeClr val="accent2"/>
                 </a:solidFill>
               </a:rPr>
-              <a:t>第2期の買収先の営業利益（ランレート、2026年予想）</a:t>
+              <a:t>飲食A社の今期営業利益。8.2億円で取得、純資産13.0億円</a:t>
             </a:r>
             <a:endParaRPr lang="en-US" sz="1050" dirty="0"/>
           </a:p>
@@ -14832,7 +14832,7 @@
       </p:sp>
       <p:sp>
         <p:nvSpPr>
-          <p:cNvPr id="21" name="stat 第2期の回収年数（買収額14.4億円÷年間営業利益）"/>
+          <p:cNvPr id="21" name="stat 飲食B事業の今期営業利益。1,400万円で取得"/>
           <p:cNvSpPr/>
           <p:nvPr/>
         </p:nvSpPr>
@@ -14919,7 +14919,7 @@
                   <a:schemeClr val="accent1"/>
                 </a:solidFill>
               </a:rPr>
-              <a:t>約6</a:t>
+              <a:t>8,000万</a:t>
             </a:r>
             <a:endParaRPr lang="en-US" sz="3600" dirty="0"/>
           </a:p>
@@ -14955,7 +14955,7 @@
                   <a:schemeClr val="tx1"/>
                 </a:solidFill>
               </a:rPr>
-              <a:t>年</a:t>
+              <a:t>円／年</a:t>
             </a:r>
             <a:endParaRPr lang="en-US" sz="1300" dirty="0"/>
           </a:p>
@@ -14991,7 +14991,7 @@
                   <a:schemeClr val="accent2"/>
                 </a:solidFill>
               </a:rPr>
-              <a:t>第2期の回収年数（買収額14.4億円÷年間営業利益）</a:t>
+              <a:t>飲食B事業の今期営業利益。1,400万円で取得</a:t>
             </a:r>
             <a:endParaRPr lang="en-US" sz="1050" dirty="0"/>
           </a:p>
@@ -15175,7 +15175,7 @@
                   <a:schemeClr val="tx1"/>
                 </a:solidFill>
               </a:rPr>
-              <a:t>純資産の9割の価格で取得し、毎年2.4億円の営業利益が上乗せされていく</a:t>
+              <a:t>主要2件だけで今期営業利益2.1億円。買収額8.3億円を約4年で回収し、純資産は買値以上</a:t>
             </a:r>
             <a:endParaRPr lang="en-US" sz="1200" dirty="0"/>
           </a:p>
@@ -15211,7 +15211,7 @@
                   <a:schemeClr val="accent5"/>
                 </a:solidFill>
               </a:rPr>
-              <a:t>単位：億円。第1期の営業利益は保有期間中の累計。第2期のランレートはM&amp;Aで取得したグループ会社の2026年予想営業利益。出典：中野邦人 M&amp;A勝敗一覧表、グループ売上管理表</a:t>
+              <a:t>単位：億円。第1期の営業利益は保有期間中の累計。グラフの第2期の利益はM&amp;Aで取得したグループ会社全体の2026年予想。出典：中野邦人 M&amp;A勝敗一覧表、グループ売上管理表</a:t>
             </a:r>
             <a:endParaRPr lang="en-US" sz="900" dirty="0"/>
           </a:p>

</xml_diff>

<commit_message>
Rework track record slide: assets vs price and grown operating profit per phase
Co-Authored-By: Claude Opus 5.5 <noreply@anthropic.com>
Claude-Session: https://claude.ai/code/session_01BZneVAifSNdK9XeKQimWEA
</commit_message>
<xml_diff>
--- a/docs/business/事業概要_AI_MA部門_営業用.pptx
+++ b/docs/business/事業概要_AI_MA部門_営業用.pptx
@@ -122,20 +122,20 @@
   <p:extLst>
     <p:ext uri="{521415D9-36F7-43E2-AB2F-B90AF26B5E84}">
       <p14:sectionLst xmlns:p14="http://schemas.microsoft.com/office/powerpoint/2010/main">
-        <p14:section name="導入" id="{99787ca1-49af-a0d0-493f-4a616528ca5c}">
+        <p14:section name="導入" id="{ef6d071b-112c-6df7-41d5-215749b93239}">
           <p14:sldIdLst>
             <p14:sldId id="256"/>
             <p14:sldId id="257"/>
           </p14:sldIdLst>
         </p14:section>
-        <p14:section name="課題と原点" id="{10529317-3af5-e863-f7a8-f85d72b9073e}">
+        <p14:section name="課題と原点" id="{7e97e339-aa46-f824-3f8c-3000868c4bf1}">
           <p14:sldIdLst>
             <p14:sldId id="258"/>
             <p14:sldId id="259"/>
             <p14:sldId id="260"/>
           </p14:sldIdLst>
         </p14:section>
-        <p14:section name="サービス" id="{5e69687d-b065-9cfb-28c0-19e10453e5f3}">
+        <p14:section name="サービス" id="{7a85cd12-701a-aa0e-d4b9-c32789afc52f}">
           <p14:sldIdLst>
             <p14:sldId id="261"/>
             <p14:sldId id="262"/>
@@ -146,14 +146,14 @@
             <p14:sldId id="267"/>
           </p14:sldIdLst>
         </p14:section>
-        <p14:section name="事業性" id="{2be83fbb-b942-16dc-8848-40aa20647929}">
+        <p14:section name="事業性" id="{8f85441d-7240-01e5-412a-4427d2d7c68a}">
           <p14:sldIdLst>
             <p14:sldId id="268"/>
             <p14:sldId id="269"/>
             <p14:sldId id="270"/>
           </p14:sldIdLst>
         </p14:section>
-        <p14:section name="まとめ" id="{219c0a43-d18b-1fba-5c6d-7042dde40b4f}">
+        <p14:section name="まとめ" id="{f6cbf5e1-e807-d012-81d5-ddb022ac79db}">
           <p14:sldIdLst>
             <p14:sldId id="271"/>
           </p14:sldIdLst>
@@ -168,533 +168,6 @@
 </file>
 
 <file path=ppt/charts/chart1.xml><?xml version="1.0" encoding="utf-8"?>
-<c:chartSpace xmlns:c="http://schemas.openxmlformats.org/drawingml/2006/chart" xmlns:a="http://schemas.openxmlformats.org/drawingml/2006/main" xmlns:r="http://schemas.openxmlformats.org/officeDocument/2006/relationships">
-  <c:date1904 val="0"/>
-  <c:roundedCorners val="1"/>
-  <c:chart>
-    <c:autoTitleDeleted val="1"/>
-    <c:plotArea>
-      <c:layout/>
-      <c:barChart>
-        <c:barDir val="bar"/>
-        <c:grouping val="stacked"/>
-        <c:varyColors val="0"/>
-        <c:ser>
-          <c:idx val="0"/>
-          <c:order val="0"/>
-          <c:tx>
-            <c:strRef>
-              <c:f>Sheet1!$B$1</c:f>
-              <c:strCache>
-                <c:ptCount val="1"/>
-                <c:pt idx="0">
-                  <c:v>投じた額</c:v>
-                </c:pt>
-              </c:strCache>
-            </c:strRef>
-          </c:tx>
-          <c:spPr>
-            <a:solidFill>
-              <a:srgbClr val="9A8F84"/>
-            </a:solidFill>
-            <a:effectLst/>
-          </c:spPr>
-          <c:invertIfNegative val="0"/>
-          <c:dLbls>
-            <c:numFmt formatCode="0.0;;;" sourceLinked="0"/>
-            <c:txPr>
-              <a:bodyPr/>
-              <a:lstStyle/>
-              <a:p>
-                <a:pPr>
-                  <a:defRPr b="0" i="0" strike="noStrike" sz="900" u="none">
-                    <a:solidFill>
-                      <a:srgbClr val="FFFFFF"/>
-                    </a:solidFill>
-                    <a:latin typeface="+mn-lt"/>
-                  </a:defRPr>
-                </a:pPr>
-              </a:p>
-            </c:txPr>
-            <c:dLblPos val="ctr"/>
-            <c:showLegendKey val="0"/>
-            <c:showVal val="1"/>
-            <c:showCatName val="0"/>
-            <c:showSerName val="0"/>
-            <c:showPercent val="0"/>
-            <c:showBubbleSize val="0"/>
-            <c:showLeaderLines val="0"/>
-          </c:dLbls>
-          <c:cat>
-            <c:multiLvlStrRef>
-              <c:f>Sheet1!$A$2:$A$5</c:f>
-              <c:multiLvlStrCache>
-                <c:ptCount val="4"/>
-                <c:lvl>
-                  <c:pt idx="0">
-                    <c:v>第1期 投じた額</c:v>
-                  </c:pt>
-                  <c:pt idx="1">
-                    <c:v>第1期 戻った額</c:v>
-                  </c:pt>
-                  <c:pt idx="2">
-                    <c:v>第2期 投じた額</c:v>
-                  </c:pt>
-                  <c:pt idx="3">
-                    <c:v>第2期 得た資産＋1年分の利益</c:v>
-                  </c:pt>
-                </c:lvl>
-              </c:multiLvlStrCache>
-            </c:multiLvlStrRef>
-          </c:cat>
-          <c:val>
-            <c:numRef>
-              <c:f>Sheet1!$B$2:$B$5</c:f>
-              <c:numCache>
-                <c:formatCode>General</c:formatCode>
-                <c:ptCount val="4"/>
-                <c:pt idx="0">
-                  <c:v>10.8</c:v>
-                </c:pt>
-                <c:pt idx="1">
-                  <c:v>0</c:v>
-                </c:pt>
-                <c:pt idx="2">
-                  <c:v>14.4</c:v>
-                </c:pt>
-                <c:pt idx="3">
-                  <c:v>0</c:v>
-                </c:pt>
-              </c:numCache>
-            </c:numRef>
-          </c:val>
-        </c:ser>
-        <c:ser>
-          <c:idx val="1"/>
-          <c:order val="1"/>
-          <c:tx>
-            <c:strRef>
-              <c:f>Sheet1!$C$1</c:f>
-              <c:strCache>
-                <c:ptCount val="1"/>
-                <c:pt idx="0">
-                  <c:v>営業利益</c:v>
-                </c:pt>
-              </c:strCache>
-            </c:strRef>
-          </c:tx>
-          <c:spPr>
-            <a:solidFill>
-              <a:srgbClr val="2B2622"/>
-            </a:solidFill>
-            <a:effectLst/>
-          </c:spPr>
-          <c:invertIfNegative val="0"/>
-          <c:dLbls>
-            <c:numFmt formatCode="0.0;;;" sourceLinked="0"/>
-            <c:txPr>
-              <a:bodyPr/>
-              <a:lstStyle/>
-              <a:p>
-                <a:pPr>
-                  <a:defRPr b="0" i="0" strike="noStrike" sz="900" u="none">
-                    <a:solidFill>
-                      <a:srgbClr val="FFFFFF"/>
-                    </a:solidFill>
-                    <a:latin typeface="+mn-lt"/>
-                  </a:defRPr>
-                </a:pPr>
-              </a:p>
-            </c:txPr>
-            <c:dLblPos val="ctr"/>
-            <c:showLegendKey val="0"/>
-            <c:showVal val="1"/>
-            <c:showCatName val="0"/>
-            <c:showSerName val="0"/>
-            <c:showPercent val="0"/>
-            <c:showBubbleSize val="0"/>
-            <c:showLeaderLines val="0"/>
-          </c:dLbls>
-          <c:cat>
-            <c:multiLvlStrRef>
-              <c:f>Sheet1!$A$2:$A$5</c:f>
-              <c:multiLvlStrCache>
-                <c:ptCount val="4"/>
-                <c:lvl>
-                  <c:pt idx="0">
-                    <c:v>第1期 投じた額</c:v>
-                  </c:pt>
-                  <c:pt idx="1">
-                    <c:v>第1期 戻った額</c:v>
-                  </c:pt>
-                  <c:pt idx="2">
-                    <c:v>第2期 投じた額</c:v>
-                  </c:pt>
-                  <c:pt idx="3">
-                    <c:v>第2期 得た資産＋1年分の利益</c:v>
-                  </c:pt>
-                </c:lvl>
-              </c:multiLvlStrCache>
-            </c:multiLvlStrRef>
-          </c:cat>
-          <c:val>
-            <c:numRef>
-              <c:f>Sheet1!$C$2:$C$5</c:f>
-              <c:numCache>
-                <c:formatCode>General</c:formatCode>
-                <c:ptCount val="4"/>
-                <c:pt idx="0">
-                  <c:v>0</c:v>
-                </c:pt>
-                <c:pt idx="1">
-                  <c:v>7.6</c:v>
-                </c:pt>
-                <c:pt idx="2">
-                  <c:v>0</c:v>
-                </c:pt>
-                <c:pt idx="3">
-                  <c:v>2.4</c:v>
-                </c:pt>
-              </c:numCache>
-            </c:numRef>
-          </c:val>
-        </c:ser>
-        <c:ser>
-          <c:idx val="2"/>
-          <c:order val="2"/>
-          <c:tx>
-            <c:strRef>
-              <c:f>Sheet1!$D$1</c:f>
-              <c:strCache>
-                <c:ptCount val="1"/>
-                <c:pt idx="0">
-                  <c:v>売却回収</c:v>
-                </c:pt>
-              </c:strCache>
-            </c:strRef>
-          </c:tx>
-          <c:spPr>
-            <a:solidFill>
-              <a:srgbClr val="C9AE7E"/>
-            </a:solidFill>
-            <a:effectLst/>
-          </c:spPr>
-          <c:invertIfNegative val="0"/>
-          <c:dLbls>
-            <c:numFmt formatCode="0.0;;;" sourceLinked="0"/>
-            <c:txPr>
-              <a:bodyPr/>
-              <a:lstStyle/>
-              <a:p>
-                <a:pPr>
-                  <a:defRPr b="0" i="0" strike="noStrike" sz="900" u="none">
-                    <a:solidFill>
-                      <a:srgbClr val="FFFFFF"/>
-                    </a:solidFill>
-                    <a:latin typeface="+mn-lt"/>
-                  </a:defRPr>
-                </a:pPr>
-              </a:p>
-            </c:txPr>
-            <c:dLblPos val="ctr"/>
-            <c:showLegendKey val="0"/>
-            <c:showVal val="1"/>
-            <c:showCatName val="0"/>
-            <c:showSerName val="0"/>
-            <c:showPercent val="0"/>
-            <c:showBubbleSize val="0"/>
-            <c:showLeaderLines val="0"/>
-          </c:dLbls>
-          <c:cat>
-            <c:multiLvlStrRef>
-              <c:f>Sheet1!$A$2:$A$5</c:f>
-              <c:multiLvlStrCache>
-                <c:ptCount val="4"/>
-                <c:lvl>
-                  <c:pt idx="0">
-                    <c:v>第1期 投じた額</c:v>
-                  </c:pt>
-                  <c:pt idx="1">
-                    <c:v>第1期 戻った額</c:v>
-                  </c:pt>
-                  <c:pt idx="2">
-                    <c:v>第2期 投じた額</c:v>
-                  </c:pt>
-                  <c:pt idx="3">
-                    <c:v>第2期 得た資産＋1年分の利益</c:v>
-                  </c:pt>
-                </c:lvl>
-              </c:multiLvlStrCache>
-            </c:multiLvlStrRef>
-          </c:cat>
-          <c:val>
-            <c:numRef>
-              <c:f>Sheet1!$D$2:$D$5</c:f>
-              <c:numCache>
-                <c:formatCode>General</c:formatCode>
-                <c:ptCount val="4"/>
-                <c:pt idx="0">
-                  <c:v>0</c:v>
-                </c:pt>
-                <c:pt idx="1">
-                  <c:v>5.3</c:v>
-                </c:pt>
-                <c:pt idx="2">
-                  <c:v>0</c:v>
-                </c:pt>
-                <c:pt idx="3">
-                  <c:v>0</c:v>
-                </c:pt>
-              </c:numCache>
-            </c:numRef>
-          </c:val>
-        </c:ser>
-        <c:ser>
-          <c:idx val="3"/>
-          <c:order val="3"/>
-          <c:tx>
-            <c:strRef>
-              <c:f>Sheet1!$E$1</c:f>
-              <c:strCache>
-                <c:ptCount val="1"/>
-                <c:pt idx="0">
-                  <c:v>手元の純資産</c:v>
-                </c:pt>
-              </c:strCache>
-            </c:strRef>
-          </c:tx>
-          <c:spPr>
-            <a:solidFill>
-              <a:srgbClr val="A78450"/>
-            </a:solidFill>
-            <a:effectLst/>
-          </c:spPr>
-          <c:invertIfNegative val="0"/>
-          <c:dLbls>
-            <c:numFmt formatCode="0.0;;;" sourceLinked="0"/>
-            <c:txPr>
-              <a:bodyPr/>
-              <a:lstStyle/>
-              <a:p>
-                <a:pPr>
-                  <a:defRPr b="0" i="0" strike="noStrike" sz="900" u="none">
-                    <a:solidFill>
-                      <a:srgbClr val="FFFFFF"/>
-                    </a:solidFill>
-                    <a:latin typeface="+mn-lt"/>
-                  </a:defRPr>
-                </a:pPr>
-              </a:p>
-            </c:txPr>
-            <c:dLblPos val="ctr"/>
-            <c:showLegendKey val="0"/>
-            <c:showVal val="1"/>
-            <c:showCatName val="0"/>
-            <c:showSerName val="0"/>
-            <c:showPercent val="0"/>
-            <c:showBubbleSize val="0"/>
-            <c:showLeaderLines val="0"/>
-          </c:dLbls>
-          <c:cat>
-            <c:multiLvlStrRef>
-              <c:f>Sheet1!$A$2:$A$5</c:f>
-              <c:multiLvlStrCache>
-                <c:ptCount val="4"/>
-                <c:lvl>
-                  <c:pt idx="0">
-                    <c:v>第1期 投じた額</c:v>
-                  </c:pt>
-                  <c:pt idx="1">
-                    <c:v>第1期 戻った額</c:v>
-                  </c:pt>
-                  <c:pt idx="2">
-                    <c:v>第2期 投じた額</c:v>
-                  </c:pt>
-                  <c:pt idx="3">
-                    <c:v>第2期 得た資産＋1年分の利益</c:v>
-                  </c:pt>
-                </c:lvl>
-              </c:multiLvlStrCache>
-            </c:multiLvlStrRef>
-          </c:cat>
-          <c:val>
-            <c:numRef>
-              <c:f>Sheet1!$E$2:$E$5</c:f>
-              <c:numCache>
-                <c:formatCode>General</c:formatCode>
-                <c:ptCount val="4"/>
-                <c:pt idx="0">
-                  <c:v>0</c:v>
-                </c:pt>
-                <c:pt idx="1">
-                  <c:v>2</c:v>
-                </c:pt>
-                <c:pt idx="2">
-                  <c:v>0</c:v>
-                </c:pt>
-                <c:pt idx="3">
-                  <c:v>15.9</c:v>
-                </c:pt>
-              </c:numCache>
-            </c:numRef>
-          </c:val>
-        </c:ser>
-        <c:dLbls>
-          <c:numFmt formatCode="0.0;;;" sourceLinked="0"/>
-          <c:txPr>
-            <a:bodyPr/>
-            <a:lstStyle/>
-            <a:p>
-              <a:pPr>
-                <a:defRPr b="0" i="0" strike="noStrike" sz="900" u="none">
-                  <a:solidFill>
-                    <a:srgbClr val="FFFFFF"/>
-                  </a:solidFill>
-                  <a:latin typeface="+mn-lt"/>
-                </a:defRPr>
-              </a:pPr>
-            </a:p>
-          </c:txPr>
-          <c:dLblPos val="ctr"/>
-          <c:showLegendKey val="0"/>
-          <c:showVal val="1"/>
-          <c:showCatName val="0"/>
-          <c:showSerName val="0"/>
-          <c:showPercent val="0"/>
-          <c:showBubbleSize val="0"/>
-          <c:showLeaderLines val="0"/>
-        </c:dLbls>
-        <c:gapWidth val="35"/>
-        <c:overlap val="100"/>
-        <c:axId val="2094734554"/>
-        <c:axId val="2094734552"/>
-        <c:axId val="2094734556"/>
-      </c:barChart>
-      <c:catAx>
-        <c:axId val="2094734554"/>
-        <c:scaling>
-          <c:orientation val="maxMin"/>
-        </c:scaling>
-        <c:delete val="0"/>
-        <c:axPos val="l"/>
-        <c:numFmt formatCode="General" sourceLinked="1"/>
-        <c:majorTickMark val="out"/>
-        <c:minorTickMark val="none"/>
-        <c:tickLblPos val="nextTo"/>
-        <c:spPr>
-          <a:ln w="12700" cap="flat">
-            <a:solidFill>
-              <a:srgbClr val="888888"/>
-            </a:solidFill>
-            <a:prstDash val="solid"/>
-            <a:round/>
-          </a:ln>
-        </c:spPr>
-        <c:txPr>
-          <a:bodyPr/>
-          <a:lstStyle/>
-          <a:p>
-            <a:pPr>
-              <a:defRPr sz="900" b="0" i="0" u="none" strike="noStrike">
-                <a:solidFill>
-                  <a:srgbClr val="2B2622"/>
-                </a:solidFill>
-                <a:latin typeface="+mn-lt"/>
-              </a:defRPr>
-            </a:pPr>
-            <a:endParaRPr lang="en-US"/>
-          </a:p>
-        </c:txPr>
-        <c:crossAx val="2094734552"/>
-        <c:crosses val="autoZero"/>
-        <c:auto val="1"/>
-        <c:lblAlgn val="ctr"/>
-        <c:noMultiLvlLbl val="1"/>
-      </c:catAx>
-      <c:valAx>
-        <c:axId val="2094734552"/>
-        <c:scaling>
-          <c:orientation val="minMax"/>
-        </c:scaling>
-        <c:delete val="1"/>
-        <c:axPos val="b"/>
-        <c:numFmt formatCode="General" sourceLinked="0"/>
-        <c:majorTickMark val="out"/>
-        <c:minorTickMark val="none"/>
-        <c:tickLblPos val="low"/>
-        <c:spPr>
-          <a:ln w="12700" cap="flat">
-            <a:solidFill>
-              <a:srgbClr val="888888"/>
-            </a:solidFill>
-            <a:prstDash val="solid"/>
-            <a:round/>
-          </a:ln>
-        </c:spPr>
-        <c:txPr>
-          <a:bodyPr/>
-          <a:lstStyle/>
-          <a:p>
-            <a:pPr>
-              <a:defRPr sz="1200" b="0" i="0" u="none" strike="noStrike">
-                <a:solidFill>
-                  <a:srgbClr val="000000"/>
-                </a:solidFill>
-                <a:latin typeface="Arial"/>
-              </a:defRPr>
-            </a:pPr>
-            <a:endParaRPr lang="en-US"/>
-          </a:p>
-        </c:txPr>
-        <c:crossAx val="2094734554"/>
-        <c:crosses val="autoZero"/>
-        <c:crossBetween val="between"/>
-      </c:valAx>
-      <c:spPr>
-        <a:noFill/>
-        <a:ln>
-          <a:noFill/>
-        </a:ln>
-        <a:effectLst/>
-      </c:spPr>
-    </c:plotArea>
-    <c:legend>
-      <c:legendPos val="r"/>
-      <c:overlay val="0"/>
-      <c:txPr>
-        <a:bodyPr/>
-        <a:lstStyle/>
-        <a:p>
-          <a:pPr>
-            <a:defRPr sz="900">
-              <a:solidFill>
-                <a:srgbClr val="6F665F"/>
-              </a:solidFill>
-              <a:latin typeface="+mn-lt"/>
-              <a:cs typeface="+mn-lt"/>
-            </a:defRPr>
-          </a:pPr>
-          <a:endParaRPr lang="en-US"/>
-        </a:p>
-      </c:txPr>
-    </c:legend>
-    <c:plotVisOnly val="1"/>
-    <c:dispBlanksAs val="span"/>
-  </c:chart>
-  <c:spPr>
-    <a:noFill/>
-    <a:ln>
-      <a:noFill/>
-    </a:ln>
-    <a:effectLst/>
-  </c:spPr>
-  <c:externalData r:id="rId1">
-    <c:autoUpdate val="0"/>
-  </c:externalData>
-</c:chartSpace>
-</file>
-
-<file path=ppt/charts/chart2.xml><?xml version="1.0" encoding="utf-8"?>
 <c:chartSpace xmlns:c="http://schemas.openxmlformats.org/drawingml/2006/chart" xmlns:a="http://schemas.openxmlformats.org/drawingml/2006/main" xmlns:r="http://schemas.openxmlformats.org/officeDocument/2006/relationships">
   <c:date1904 val="0"/>
   <c:roundedCorners val="1"/>
@@ -2432,7 +1905,7 @@
           <a:p>
             <a:r>
               <a:rPr lang="en-US" dirty="0"/>
-              <a:t>第1期は投じた10.8億が14.9億で戻った。第2期は純資産より安く買っているので、買った瞬間に資産で元が取れている。飲食A社は8.2億で買って今期の営業利益1.3億、飲食B事業は1,400万で買って今期8,000万。この2件だけで年2.1億、約4年で買収額を利益で回収できる。</a:t>
+              <a:t>見るのは2つ。買った値段に対して資産がいくら残ったか、営業利益がいくらに育ったか。第1期は資産では0.7倍、ただ保有中に7.6億の営業利益を出した。第2期は純資産より安く買っているので、資産は買値の1.3倍。そのうえ単年度で2.4億の営業利益に育っている。飲食A社は8.2億で買って純資産13億、今期の営業利益1.3億。飲食B事業は1,400万で買って純資産7,000万、今期8,000万。</a:t>
             </a:r>
             <a:endParaRPr lang="en-US" dirty="0"/>
           </a:p>
@@ -14285,7 +13758,7 @@
                   <a:schemeClr val="tx1"/>
                 </a:solidFill>
               </a:rPr>
-              <a:t>49戦の実績：安く買い、利益と資産で回収する</a:t>
+              <a:t>49戦の実績：純資産より安く買い、営業利益を積み上げる</a:t>
             </a:r>
             <a:endParaRPr lang="en-US" sz="3000" dirty="0"/>
           </a:p>
@@ -14323,7 +13796,7 @@
                   <a:schemeClr val="accent2"/>
                 </a:solidFill>
               </a:rPr>
-              <a:t>買収額を「いくらの利益と資産が手に入ったか」で測る。2011年3月〜現在、すべて自社の実案件</a:t>
+              <a:t>買った値段に対して「手元に残った資産（売却額を含む）」と「育った営業利益」で測る。すべて自社の実案件</a:t>
             </a:r>
             <a:endParaRPr lang="en-US" sz="1350" dirty="0"/>
           </a:p>
@@ -14331,18 +13804,18 @@
       </p:sp>
       <p:sp>
         <p:nvSpPr>
-          <p:cNvPr id="6" name="stat 第1期の回収倍率。投じた10.8億円が14.9億円で戻った"/>
+          <p:cNvPr id="6" name="panel 第1期 2011–19"/>
           <p:cNvSpPr/>
           <p:nvPr/>
         </p:nvSpPr>
         <p:spPr>
           <a:xfrm>
             <a:off x="685800" y="2011680"/>
-            <a:ext cx="2560320" cy="1901952"/>
+            <a:ext cx="5349240" cy="4041648"/>
           </a:xfrm>
           <a:prstGeom prst="roundRect">
             <a:avLst>
-              <a:gd name="adj" fmla="val 2885"/>
+              <a:gd name="adj" fmla="val 1357"/>
             </a:avLst>
           </a:prstGeom>
           <a:solidFill>
@@ -14371,11 +13844,13 @@
         </p:nvSpPr>
         <p:spPr>
           <a:xfrm>
-            <a:off x="941832" y="2286000"/>
-            <a:ext cx="365760" cy="45720"/>
-          </a:xfrm>
-          <a:prstGeom prst="rect">
-            <a:avLst/>
+            <a:off x="960120" y="2212848"/>
+            <a:ext cx="1417320" cy="274320"/>
+          </a:xfrm>
+          <a:prstGeom prst="roundRect">
+            <a:avLst>
+              <a:gd name="adj" fmla="val 50000"/>
+            </a:avLst>
           </a:prstGeom>
           <a:solidFill>
             <a:schemeClr val="accent1"/>
@@ -14396,8 +13871,8 @@
         </p:nvSpPr>
         <p:spPr>
           <a:xfrm>
-            <a:off x="923544" y="2450592"/>
-            <a:ext cx="2103120" cy="777240"/>
+            <a:off x="960120" y="2212848"/>
+            <a:ext cx="1417320" cy="274320"/>
           </a:xfrm>
           <a:prstGeom prst="rect">
             <a:avLst/>
@@ -14409,18 +13884,18 @@
           <a:bodyPr wrap="square" lIns="0" tIns="0" rIns="0" bIns="0" rtlCol="0" anchor="ctr"/>
           <a:lstStyle/>
           <a:p>
-            <a:pPr indent="0" marL="0">
-              <a:buNone/>
-            </a:pPr>
-            <a:r>
-              <a:rPr lang="en-US" sz="3600" b="1" dirty="0">
-                <a:solidFill>
-                  <a:schemeClr val="accent1"/>
-                </a:solidFill>
-              </a:rPr>
-              <a:t>1.4</a:t>
-            </a:r>
-            <a:endParaRPr lang="en-US" sz="3600" dirty="0"/>
+            <a:pPr algn="ctr" indent="0" marL="0">
+              <a:buNone/>
+            </a:pPr>
+            <a:r>
+              <a:rPr lang="en-US" sz="950" b="1" dirty="0">
+                <a:solidFill>
+                  <a:schemeClr val="bg1"/>
+                </a:solidFill>
+              </a:rPr>
+              <a:t>第1期 2011–19</a:t>
+            </a:r>
+            <a:endParaRPr lang="en-US" sz="950" dirty="0"/>
           </a:p>
         </p:txBody>
       </p:sp>
@@ -14432,31 +13907,31 @@
         </p:nvSpPr>
         <p:spPr>
           <a:xfrm>
-            <a:off x="923544" y="3227832"/>
-            <a:ext cx="2103120" cy="274320"/>
-          </a:xfrm>
-          <a:prstGeom prst="rect">
-            <a:avLst/>
-          </a:prstGeom>
-          <a:noFill/>
-          <a:ln/>
-        </p:spPr>
-        <p:txBody>
-          <a:bodyPr wrap="square" lIns="0" tIns="0" rIns="0" bIns="0" rtlCol="0" anchor="t"/>
-          <a:lstStyle/>
-          <a:p>
-            <a:pPr indent="0" marL="0">
-              <a:buNone/>
-            </a:pPr>
-            <a:r>
-              <a:rPr lang="en-US" sz="1300" b="1" dirty="0">
+            <a:off x="2514600" y="2176272"/>
+            <a:ext cx="3291840" cy="347472"/>
+          </a:xfrm>
+          <a:prstGeom prst="rect">
+            <a:avLst/>
+          </a:prstGeom>
+          <a:noFill/>
+          <a:ln/>
+        </p:spPr>
+        <p:txBody>
+          <a:bodyPr wrap="square" lIns="0" tIns="0" rIns="0" bIns="0" rtlCol="0" anchor="ctr"/>
+          <a:lstStyle/>
+          <a:p>
+            <a:pPr indent="0" marL="0">
+              <a:buNone/>
+            </a:pPr>
+            <a:r>
+              <a:rPr lang="en-US" sz="1400" b="1" dirty="0">
                 <a:solidFill>
                   <a:schemeClr val="tx1"/>
                 </a:solidFill>
               </a:rPr>
-              <a:t>倍</a:t>
-            </a:r>
-            <a:endParaRPr lang="en-US" sz="1300" dirty="0"/>
+              <a:t>数で獲りにいき、授業料も払った</a:t>
+            </a:r>
+            <a:endParaRPr lang="en-US" sz="1400" dirty="0"/>
           </a:p>
         </p:txBody>
       </p:sp>
@@ -14468,81 +13943,616 @@
         </p:nvSpPr>
         <p:spPr>
           <a:xfrm>
-            <a:off x="923544" y="3502152"/>
-            <a:ext cx="2103120" cy="301752"/>
-          </a:xfrm>
-          <a:prstGeom prst="rect">
-            <a:avLst/>
-          </a:prstGeom>
-          <a:noFill/>
-          <a:ln/>
-        </p:spPr>
-        <p:txBody>
-          <a:bodyPr wrap="square" lIns="0" tIns="0" rIns="0" bIns="0" rtlCol="0" anchor="t"/>
-          <a:lstStyle/>
-          <a:p>
-            <a:pPr indent="0" marL="0">
-              <a:buNone/>
-            </a:pPr>
-            <a:r>
-              <a:rPr lang="en-US" sz="1050" dirty="0">
+            <a:off x="960120" y="2743200"/>
+            <a:ext cx="1051560" cy="384048"/>
+          </a:xfrm>
+          <a:prstGeom prst="rect">
+            <a:avLst/>
+          </a:prstGeom>
+          <a:noFill/>
+          <a:ln/>
+        </p:spPr>
+        <p:txBody>
+          <a:bodyPr wrap="square" lIns="0" tIns="0" rIns="0" bIns="0" rtlCol="0" anchor="ctr"/>
+          <a:lstStyle/>
+          <a:p>
+            <a:pPr indent="0" marL="0">
+              <a:buNone/>
+            </a:pPr>
+            <a:r>
+              <a:rPr lang="en-US" sz="1100" b="1" dirty="0">
                 <a:solidFill>
                   <a:schemeClr val="accent2"/>
                 </a:solidFill>
               </a:rPr>
-              <a:t>第1期の回収倍率。投じた10.8億円が14.9億円で戻った</a:t>
-            </a:r>
-            <a:endParaRPr lang="en-US" sz="1050" dirty="0"/>
-          </a:p>
-        </p:txBody>
-      </p:sp>
-      <p:sp>
-        <p:nvSpPr>
-          <p:cNvPr id="11" name="stat 第2期の純資産倍率。14.4億円で純資産15.9億円を取得"/>
-          <p:cNvSpPr/>
-          <p:nvPr/>
-        </p:nvSpPr>
-        <p:spPr>
-          <a:xfrm>
-            <a:off x="3456432" y="2011680"/>
-            <a:ext cx="2560320" cy="1901952"/>
-          </a:xfrm>
-          <a:prstGeom prst="roundRect">
-            <a:avLst>
-              <a:gd name="adj" fmla="val 2885"/>
-            </a:avLst>
+              <a:t>購入額</a:t>
+            </a:r>
+            <a:endParaRPr lang="en-US" sz="1100" dirty="0"/>
+          </a:p>
+        </p:txBody>
+      </p:sp>
+      <p:sp>
+        <p:nvSpPr>
+          <p:cNvPr id="11" name="第1期 2011–19 bar 購入額"/>
+          <p:cNvSpPr/>
+          <p:nvPr/>
+        </p:nvSpPr>
+        <p:spPr>
+          <a:xfrm>
+            <a:off x="2011680" y="2779776"/>
+            <a:ext cx="1085222" cy="310896"/>
+          </a:xfrm>
+          <a:prstGeom prst="rect">
+            <a:avLst/>
           </a:prstGeom>
           <a:solidFill>
-            <a:schemeClr val="bg2"/>
+            <a:srgbClr val="9A8F84"/>
           </a:solidFill>
-          <a:ln w="9525">
+          <a:ln w="12700">
             <a:solidFill>
-              <a:schemeClr val="accent3"/>
+              <a:srgbClr val="9A8F84"/>
             </a:solidFill>
             <a:prstDash val="solid"/>
           </a:ln>
-          <a:effectLst>
-            <a:outerShdw sx="100000" sy="100000" kx="0" ky="0" algn="bl" rotWithShape="0" blurRad="76200" dist="25400" dir="5400000">
-              <a:srgbClr val="6F665F">
-                <a:alpha val="12000"/>
-              </a:srgbClr>
-            </a:outerShdw>
-          </a:effectLst>
-        </p:spPr>
-      </p:sp>
-      <p:sp>
-        <p:nvSpPr>
-          <p:cNvPr id="12" name="Shape 10"/>
-          <p:cNvSpPr/>
-          <p:nvPr/>
-        </p:nvSpPr>
-        <p:spPr>
-          <a:xfrm>
-            <a:off x="3712464" y="2286000"/>
-            <a:ext cx="365760" cy="45720"/>
-          </a:xfrm>
-          <a:prstGeom prst="rect">
-            <a:avLst/>
+        </p:spPr>
+      </p:sp>
+      <p:sp>
+        <p:nvSpPr>
+          <p:cNvPr id="12" name="Text 10"/>
+          <p:cNvSpPr txBox="1"/>
+          <p:nvPr/>
+        </p:nvSpPr>
+        <p:spPr>
+          <a:xfrm>
+            <a:off x="3170054" y="2743200"/>
+            <a:ext cx="822960" cy="384048"/>
+          </a:xfrm>
+          <a:prstGeom prst="rect">
+            <a:avLst/>
+          </a:prstGeom>
+          <a:noFill/>
+          <a:ln/>
+        </p:spPr>
+        <p:txBody>
+          <a:bodyPr wrap="square" lIns="0" tIns="0" rIns="0" bIns="0" rtlCol="0" anchor="ctr"/>
+          <a:lstStyle/>
+          <a:p>
+            <a:pPr indent="0" marL="0">
+              <a:buNone/>
+            </a:pPr>
+            <a:r>
+              <a:rPr lang="en-US" sz="1200" b="1" dirty="0">
+                <a:solidFill>
+                  <a:schemeClr val="tx1"/>
+                </a:solidFill>
+              </a:rPr>
+              <a:t>10.8億</a:t>
+            </a:r>
+            <a:endParaRPr lang="en-US" sz="1200" dirty="0"/>
+          </a:p>
+        </p:txBody>
+      </p:sp>
+      <p:sp>
+        <p:nvSpPr>
+          <p:cNvPr id="13" name="Text 11"/>
+          <p:cNvSpPr txBox="1"/>
+          <p:nvPr/>
+        </p:nvSpPr>
+        <p:spPr>
+          <a:xfrm>
+            <a:off x="960120" y="3246120"/>
+            <a:ext cx="1051560" cy="384048"/>
+          </a:xfrm>
+          <a:prstGeom prst="rect">
+            <a:avLst/>
+          </a:prstGeom>
+          <a:noFill/>
+          <a:ln/>
+        </p:spPr>
+        <p:txBody>
+          <a:bodyPr wrap="square" lIns="0" tIns="0" rIns="0" bIns="0" rtlCol="0" anchor="ctr"/>
+          <a:lstStyle/>
+          <a:p>
+            <a:pPr indent="0" marL="0">
+              <a:buNone/>
+            </a:pPr>
+            <a:r>
+              <a:rPr lang="en-US" sz="1100" b="1" dirty="0">
+                <a:solidFill>
+                  <a:schemeClr val="accent2"/>
+                </a:solidFill>
+              </a:rPr>
+              <a:t>純資産＋売却</a:t>
+            </a:r>
+            <a:endParaRPr lang="en-US" sz="1100" dirty="0"/>
+          </a:p>
+        </p:txBody>
+      </p:sp>
+      <p:sp>
+        <p:nvSpPr>
+          <p:cNvPr id="14" name="第1期 2011–19 bar 純資産＋売却"/>
+          <p:cNvSpPr/>
+          <p:nvPr/>
+        </p:nvSpPr>
+        <p:spPr>
+          <a:xfrm>
+            <a:off x="2011680" y="3282696"/>
+            <a:ext cx="733530" cy="310896"/>
+          </a:xfrm>
+          <a:prstGeom prst="rect">
+            <a:avLst/>
+          </a:prstGeom>
+          <a:solidFill>
+            <a:srgbClr val="A78450"/>
+          </a:solidFill>
+          <a:ln w="12700">
+            <a:solidFill>
+              <a:srgbClr val="A78450"/>
+            </a:solidFill>
+            <a:prstDash val="solid"/>
+          </a:ln>
+        </p:spPr>
+      </p:sp>
+      <p:sp>
+        <p:nvSpPr>
+          <p:cNvPr id="15" name="Text 13"/>
+          <p:cNvSpPr txBox="1"/>
+          <p:nvPr/>
+        </p:nvSpPr>
+        <p:spPr>
+          <a:xfrm>
+            <a:off x="2818362" y="3246120"/>
+            <a:ext cx="822960" cy="384048"/>
+          </a:xfrm>
+          <a:prstGeom prst="rect">
+            <a:avLst/>
+          </a:prstGeom>
+          <a:noFill/>
+          <a:ln/>
+        </p:spPr>
+        <p:txBody>
+          <a:bodyPr wrap="square" lIns="0" tIns="0" rIns="0" bIns="0" rtlCol="0" anchor="ctr"/>
+          <a:lstStyle/>
+          <a:p>
+            <a:pPr indent="0" marL="0">
+              <a:buNone/>
+            </a:pPr>
+            <a:r>
+              <a:rPr lang="en-US" sz="1200" b="1" dirty="0">
+                <a:solidFill>
+                  <a:schemeClr val="tx1"/>
+                </a:solidFill>
+              </a:rPr>
+              <a:t>7.3億</a:t>
+            </a:r>
+            <a:endParaRPr lang="en-US" sz="1200" dirty="0"/>
+          </a:p>
+        </p:txBody>
+      </p:sp>
+      <p:sp>
+        <p:nvSpPr>
+          <p:cNvPr id="16" name="Text 14"/>
+          <p:cNvSpPr txBox="1"/>
+          <p:nvPr/>
+        </p:nvSpPr>
+        <p:spPr>
+          <a:xfrm>
+            <a:off x="4617720" y="2651760"/>
+            <a:ext cx="1234440" cy="1051560"/>
+          </a:xfrm>
+          <a:prstGeom prst="rect">
+            <a:avLst/>
+          </a:prstGeom>
+          <a:noFill/>
+          <a:ln/>
+        </p:spPr>
+        <p:txBody>
+          <a:bodyPr wrap="square" lIns="0" tIns="0" rIns="0" bIns="0" rtlCol="0" anchor="ctr"/>
+          <a:lstStyle/>
+          <a:p>
+            <a:pPr algn="r" indent="0" marL="0">
+              <a:buNone/>
+            </a:pPr>
+            <a:r>
+              <a:rPr lang="en-US" sz="2800" b="1" dirty="0">
+                <a:solidFill>
+                  <a:schemeClr val="accent1"/>
+                </a:solidFill>
+              </a:rPr>
+              <a:t>0.7倍</a:t>
+            </a:r>
+            <a:endParaRPr lang="en-US" sz="1300" dirty="0"/>
+          </a:p>
+          <a:p>
+            <a:pPr algn="r" indent="0" marL="0">
+              <a:buNone/>
+            </a:pPr>
+            <a:r>
+              <a:rPr lang="en-US" sz="900" dirty="0">
+                <a:solidFill>
+                  <a:schemeClr val="accent2"/>
+                </a:solidFill>
+              </a:rPr>
+              <a:t>購入額に対する資産</a:t>
+            </a:r>
+            <a:endParaRPr lang="en-US" sz="1300" dirty="0"/>
+          </a:p>
+        </p:txBody>
+      </p:sp>
+      <p:sp>
+        <p:nvSpPr>
+          <p:cNvPr id="17" name="Shape 15"/>
+          <p:cNvSpPr/>
+          <p:nvPr/>
+        </p:nvSpPr>
+        <p:spPr>
+          <a:xfrm>
+            <a:off x="960120" y="3840480"/>
+            <a:ext cx="4800600" cy="0"/>
+          </a:xfrm>
+          <a:prstGeom prst="line">
+            <a:avLst/>
+          </a:prstGeom>
+          <a:noFill/>
+          <a:ln w="9525">
+            <a:solidFill>
+              <a:srgbClr val="E6DCCB"/>
+            </a:solidFill>
+            <a:prstDash val="solid"/>
+          </a:ln>
+        </p:spPr>
+      </p:sp>
+      <p:sp>
+        <p:nvSpPr>
+          <p:cNvPr id="18" name="Text 16"/>
+          <p:cNvSpPr txBox="1"/>
+          <p:nvPr/>
+        </p:nvSpPr>
+        <p:spPr>
+          <a:xfrm>
+            <a:off x="960120" y="3931920"/>
+            <a:ext cx="2377440" cy="274320"/>
+          </a:xfrm>
+          <a:prstGeom prst="rect">
+            <a:avLst/>
+          </a:prstGeom>
+          <a:noFill/>
+          <a:ln/>
+        </p:spPr>
+        <p:txBody>
+          <a:bodyPr wrap="square" lIns="0" tIns="0" rIns="0" bIns="0" rtlCol="0" anchor="t"/>
+          <a:lstStyle/>
+          <a:p>
+            <a:pPr indent="0" marL="0">
+              <a:buNone/>
+            </a:pPr>
+            <a:r>
+              <a:rPr lang="en-US" sz="1100" b="1" dirty="0">
+                <a:solidFill>
+                  <a:schemeClr val="accent2"/>
+                </a:solidFill>
+              </a:rPr>
+              <a:t>保有期間中の営業利益</a:t>
+            </a:r>
+            <a:endParaRPr lang="en-US" sz="1100" dirty="0"/>
+          </a:p>
+        </p:txBody>
+      </p:sp>
+      <p:sp>
+        <p:nvSpPr>
+          <p:cNvPr id="19" name="Text 17"/>
+          <p:cNvSpPr txBox="1"/>
+          <p:nvPr/>
+        </p:nvSpPr>
+        <p:spPr>
+          <a:xfrm>
+            <a:off x="960120" y="4206240"/>
+            <a:ext cx="2468880" cy="640080"/>
+          </a:xfrm>
+          <a:prstGeom prst="rect">
+            <a:avLst/>
+          </a:prstGeom>
+          <a:noFill/>
+          <a:ln/>
+        </p:spPr>
+        <p:txBody>
+          <a:bodyPr wrap="square" lIns="0" tIns="0" rIns="0" bIns="0" rtlCol="0" anchor="ctr"/>
+          <a:lstStyle/>
+          <a:p>
+            <a:pPr indent="0" marL="0">
+              <a:buNone/>
+            </a:pPr>
+            <a:r>
+              <a:rPr lang="en-US" sz="3000" b="1" dirty="0">
+                <a:solidFill>
+                  <a:schemeClr val="tx1"/>
+                </a:solidFill>
+              </a:rPr>
+              <a:t>累計7.6</a:t>
+            </a:r>
+            <a:pPr indent="0" marL="0">
+              <a:buNone/>
+            </a:pPr>
+            <a:r>
+              <a:rPr lang="en-US" sz="1200" b="1" dirty="0">
+                <a:solidFill>
+                  <a:schemeClr val="accent2"/>
+                </a:solidFill>
+              </a:rPr>
+              <a:t> 億円</a:t>
+            </a:r>
+            <a:endParaRPr lang="en-US" sz="1300" dirty="0"/>
+          </a:p>
+        </p:txBody>
+      </p:sp>
+      <p:sp>
+        <p:nvSpPr>
+          <p:cNvPr id="20" name="Text 18"/>
+          <p:cNvSpPr txBox="1"/>
+          <p:nvPr/>
+        </p:nvSpPr>
+        <p:spPr>
+          <a:xfrm>
+            <a:off x="960120" y="4846320"/>
+            <a:ext cx="2377440" cy="457200"/>
+          </a:xfrm>
+          <a:prstGeom prst="rect">
+            <a:avLst/>
+          </a:prstGeom>
+          <a:noFill/>
+          <a:ln/>
+        </p:spPr>
+        <p:txBody>
+          <a:bodyPr wrap="square" lIns="0" tIns="0" rIns="0" bIns="0" rtlCol="0" anchor="t"/>
+          <a:lstStyle/>
+          <a:p>
+            <a:pPr indent="0" marL="0">
+              <a:buNone/>
+            </a:pPr>
+            <a:r>
+              <a:rPr lang="en-US" sz="950" dirty="0">
+                <a:solidFill>
+                  <a:schemeClr val="accent2"/>
+                </a:solidFill>
+              </a:rPr>
+              <a:t>資産と合わせると14.9億円が戻った</a:t>
+            </a:r>
+            <a:endParaRPr lang="en-US" sz="950" dirty="0"/>
+          </a:p>
+        </p:txBody>
+      </p:sp>
+      <p:sp>
+        <p:nvSpPr>
+          <p:cNvPr id="21" name="第1期 2011–19 deal 1"/>
+          <p:cNvSpPr/>
+          <p:nvPr/>
+        </p:nvSpPr>
+        <p:spPr>
+          <a:xfrm>
+            <a:off x="3474720" y="3977640"/>
+            <a:ext cx="2286000" cy="594360"/>
+          </a:xfrm>
+          <a:prstGeom prst="roundRect">
+            <a:avLst>
+              <a:gd name="adj" fmla="val 7692"/>
+            </a:avLst>
+          </a:prstGeom>
+          <a:solidFill>
+            <a:schemeClr val="bg1"/>
+          </a:solidFill>
+          <a:ln w="12700">
+            <a:solidFill>
+              <a:srgbClr val="E6DCCB"/>
+            </a:solidFill>
+            <a:prstDash val="solid"/>
+          </a:ln>
+        </p:spPr>
+      </p:sp>
+      <p:sp>
+        <p:nvSpPr>
+          <p:cNvPr id="22" name="Text 20"/>
+          <p:cNvSpPr txBox="1"/>
+          <p:nvPr/>
+        </p:nvSpPr>
+        <p:spPr>
+          <a:xfrm>
+            <a:off x="3566160" y="3977640"/>
+            <a:ext cx="2148840" cy="594360"/>
+          </a:xfrm>
+          <a:prstGeom prst="rect">
+            <a:avLst/>
+          </a:prstGeom>
+          <a:noFill/>
+          <a:ln/>
+        </p:spPr>
+        <p:txBody>
+          <a:bodyPr wrap="square" lIns="0" tIns="0" rIns="0" bIns="0" rtlCol="0" anchor="ctr"/>
+          <a:lstStyle/>
+          <a:p>
+            <a:pPr indent="0" marL="0">
+              <a:buNone/>
+            </a:pPr>
+            <a:r>
+              <a:rPr lang="en-US" sz="1050" b="1" dirty="0">
+                <a:solidFill>
+                  <a:schemeClr val="tx1"/>
+                </a:solidFill>
+              </a:rPr>
+              <a:t>多店舗飲食C社（25店舗）</a:t>
+            </a:r>
+            <a:endParaRPr lang="en-US" sz="1300" dirty="0"/>
+          </a:p>
+          <a:p>
+            <a:pPr indent="0" marL="0">
+              <a:buNone/>
+            </a:pPr>
+            <a:r>
+              <a:rPr lang="en-US" sz="900" dirty="0">
+                <a:solidFill>
+                  <a:schemeClr val="accent2"/>
+                </a:solidFill>
+              </a:rPr>
+              <a:t>3.3億円で取得 → 累計営業利益3.9億円</a:t>
+            </a:r>
+            <a:endParaRPr lang="en-US" sz="1300" dirty="0"/>
+          </a:p>
+        </p:txBody>
+      </p:sp>
+      <p:sp>
+        <p:nvSpPr>
+          <p:cNvPr id="23" name="第1期 2011–19 deal 2"/>
+          <p:cNvSpPr/>
+          <p:nvPr/>
+        </p:nvSpPr>
+        <p:spPr>
+          <a:xfrm>
+            <a:off x="3474720" y="4663440"/>
+            <a:ext cx="2286000" cy="594360"/>
+          </a:xfrm>
+          <a:prstGeom prst="roundRect">
+            <a:avLst>
+              <a:gd name="adj" fmla="val 7692"/>
+            </a:avLst>
+          </a:prstGeom>
+          <a:solidFill>
+            <a:schemeClr val="bg1"/>
+          </a:solidFill>
+          <a:ln w="12700">
+            <a:solidFill>
+              <a:srgbClr val="E6DCCB"/>
+            </a:solidFill>
+            <a:prstDash val="solid"/>
+          </a:ln>
+        </p:spPr>
+      </p:sp>
+      <p:sp>
+        <p:nvSpPr>
+          <p:cNvPr id="24" name="Text 22"/>
+          <p:cNvSpPr txBox="1"/>
+          <p:nvPr/>
+        </p:nvSpPr>
+        <p:spPr>
+          <a:xfrm>
+            <a:off x="3566160" y="4663440"/>
+            <a:ext cx="2148840" cy="594360"/>
+          </a:xfrm>
+          <a:prstGeom prst="rect">
+            <a:avLst/>
+          </a:prstGeom>
+          <a:noFill/>
+          <a:ln/>
+        </p:spPr>
+        <p:txBody>
+          <a:bodyPr wrap="square" lIns="0" tIns="0" rIns="0" bIns="0" rtlCol="0" anchor="ctr"/>
+          <a:lstStyle/>
+          <a:p>
+            <a:pPr indent="0" marL="0">
+              <a:buNone/>
+            </a:pPr>
+            <a:r>
+              <a:rPr lang="en-US" sz="1050" b="1" dirty="0">
+                <a:solidFill>
+                  <a:schemeClr val="tx1"/>
+                </a:solidFill>
+              </a:rPr>
+              <a:t>ポータル事業D</a:t>
+            </a:r>
+            <a:endParaRPr lang="en-US" sz="1300" dirty="0"/>
+          </a:p>
+          <a:p>
+            <a:pPr indent="0" marL="0">
+              <a:buNone/>
+            </a:pPr>
+            <a:r>
+              <a:rPr lang="en-US" sz="900" dirty="0">
+                <a:solidFill>
+                  <a:schemeClr val="accent2"/>
+                </a:solidFill>
+              </a:rPr>
+              <a:t>1,100万円で取得 → 累計1.7億円</a:t>
+            </a:r>
+            <a:endParaRPr lang="en-US" sz="1300" dirty="0"/>
+          </a:p>
+        </p:txBody>
+      </p:sp>
+      <p:sp>
+        <p:nvSpPr>
+          <p:cNvPr id="25" name="Text 23"/>
+          <p:cNvSpPr txBox="1"/>
+          <p:nvPr/>
+        </p:nvSpPr>
+        <p:spPr>
+          <a:xfrm>
+            <a:off x="960120" y="5440680"/>
+            <a:ext cx="4800600" cy="502920"/>
+          </a:xfrm>
+          <a:prstGeom prst="rect">
+            <a:avLst/>
+          </a:prstGeom>
+          <a:noFill/>
+          <a:ln/>
+        </p:spPr>
+        <p:txBody>
+          <a:bodyPr wrap="square" lIns="0" tIns="0" rIns="0" bIns="0" rtlCol="0" anchor="ctr"/>
+          <a:lstStyle/>
+          <a:p>
+            <a:pPr indent="0" marL="0">
+              <a:buNone/>
+            </a:pPr>
+            <a:r>
+              <a:rPr lang="en-US" sz="1150" b="1" dirty="0">
+                <a:solidFill>
+                  <a:schemeClr val="accent1"/>
+                </a:solidFill>
+              </a:rPr>
+              <a:t>負けも含めて、この9年がいまの判断ルールになった</a:t>
+            </a:r>
+            <a:endParaRPr lang="en-US" sz="1150" dirty="0"/>
+          </a:p>
+        </p:txBody>
+      </p:sp>
+      <p:sp>
+        <p:nvSpPr>
+          <p:cNvPr id="26" name="panel 第2期 2020–"/>
+          <p:cNvSpPr/>
+          <p:nvPr/>
+        </p:nvSpPr>
+        <p:spPr>
+          <a:xfrm>
+            <a:off x="6172200" y="2011680"/>
+            <a:ext cx="5349240" cy="4041648"/>
+          </a:xfrm>
+          <a:prstGeom prst="roundRect">
+            <a:avLst>
+              <a:gd name="adj" fmla="val 1357"/>
+            </a:avLst>
+          </a:prstGeom>
+          <a:solidFill>
+            <a:schemeClr val="tx1"/>
+          </a:solidFill>
+          <a:ln w="12700">
+            <a:solidFill>
+              <a:schemeClr val="tx1"/>
+            </a:solidFill>
+            <a:prstDash val="solid"/>
+          </a:ln>
+        </p:spPr>
+      </p:sp>
+      <p:sp>
+        <p:nvSpPr>
+          <p:cNvPr id="27" name="Shape 25"/>
+          <p:cNvSpPr/>
+          <p:nvPr/>
+        </p:nvSpPr>
+        <p:spPr>
+          <a:xfrm>
+            <a:off x="6446520" y="2212848"/>
+            <a:ext cx="1417320" cy="274320"/>
+          </a:xfrm>
+          <a:prstGeom prst="roundRect">
+            <a:avLst>
+              <a:gd name="adj" fmla="val 50000"/>
+            </a:avLst>
           </a:prstGeom>
           <a:solidFill>
             <a:schemeClr val="accent1"/>
@@ -14557,14 +14567,14 @@
       </p:sp>
       <p:sp>
         <p:nvSpPr>
-          <p:cNvPr id="13" name="Text 11"/>
+          <p:cNvPr id="28" name="Text 26"/>
           <p:cNvSpPr txBox="1"/>
           <p:nvPr/>
         </p:nvSpPr>
         <p:spPr>
           <a:xfrm>
-            <a:off x="3694176" y="2450592"/>
-            <a:ext cx="2103120" cy="777240"/>
+            <a:off x="6446520" y="2212848"/>
+            <a:ext cx="1417320" cy="274320"/>
           </a:xfrm>
           <a:prstGeom prst="rect">
             <a:avLst/>
@@ -14576,147 +14586,210 @@
           <a:bodyPr wrap="square" lIns="0" tIns="0" rIns="0" bIns="0" rtlCol="0" anchor="ctr"/>
           <a:lstStyle/>
           <a:p>
-            <a:pPr indent="0" marL="0">
-              <a:buNone/>
-            </a:pPr>
-            <a:r>
-              <a:rPr lang="en-US" sz="3600" b="1" dirty="0">
-                <a:solidFill>
-                  <a:schemeClr val="accent1"/>
-                </a:solidFill>
-              </a:rPr>
-              <a:t>0.9</a:t>
-            </a:r>
-            <a:endParaRPr lang="en-US" sz="3600" dirty="0"/>
-          </a:p>
-        </p:txBody>
-      </p:sp>
-      <p:sp>
-        <p:nvSpPr>
-          <p:cNvPr id="14" name="Text 12"/>
+            <a:pPr algn="ctr" indent="0" marL="0">
+              <a:buNone/>
+            </a:pPr>
+            <a:r>
+              <a:rPr lang="en-US" sz="950" b="1" dirty="0">
+                <a:solidFill>
+                  <a:schemeClr val="bg1"/>
+                </a:solidFill>
+              </a:rPr>
+              <a:t>第2期 2020–</a:t>
+            </a:r>
+            <a:endParaRPr lang="en-US" sz="950" dirty="0"/>
+          </a:p>
+        </p:txBody>
+      </p:sp>
+      <p:sp>
+        <p:nvSpPr>
+          <p:cNvPr id="29" name="Text 27"/>
           <p:cNvSpPr txBox="1"/>
           <p:nvPr/>
         </p:nvSpPr>
         <p:spPr>
           <a:xfrm>
-            <a:off x="3694176" y="3227832"/>
-            <a:ext cx="2103120" cy="274320"/>
-          </a:xfrm>
-          <a:prstGeom prst="rect">
-            <a:avLst/>
-          </a:prstGeom>
-          <a:noFill/>
-          <a:ln/>
-        </p:spPr>
-        <p:txBody>
-          <a:bodyPr wrap="square" lIns="0" tIns="0" rIns="0" bIns="0" rtlCol="0" anchor="t"/>
-          <a:lstStyle/>
-          <a:p>
-            <a:pPr indent="0" marL="0">
-              <a:buNone/>
-            </a:pPr>
-            <a:r>
-              <a:rPr lang="en-US" sz="1300" b="1" dirty="0">
-                <a:solidFill>
-                  <a:schemeClr val="tx1"/>
-                </a:solidFill>
-              </a:rPr>
-              <a:t>倍</a:t>
-            </a:r>
-            <a:endParaRPr lang="en-US" sz="1300" dirty="0"/>
-          </a:p>
-        </p:txBody>
-      </p:sp>
-      <p:sp>
-        <p:nvSpPr>
-          <p:cNvPr id="15" name="Text 13"/>
+            <a:off x="8001000" y="2176272"/>
+            <a:ext cx="3291840" cy="347472"/>
+          </a:xfrm>
+          <a:prstGeom prst="rect">
+            <a:avLst/>
+          </a:prstGeom>
+          <a:noFill/>
+          <a:ln/>
+        </p:spPr>
+        <p:txBody>
+          <a:bodyPr wrap="square" lIns="0" tIns="0" rIns="0" bIns="0" rtlCol="0" anchor="ctr"/>
+          <a:lstStyle/>
+          <a:p>
+            <a:pPr indent="0" marL="0">
+              <a:buNone/>
+            </a:pPr>
+            <a:r>
+              <a:rPr lang="en-US" sz="1400" b="1" dirty="0">
+                <a:solidFill>
+                  <a:schemeClr val="accent4"/>
+                </a:solidFill>
+              </a:rPr>
+              <a:t>純資産より安く買う</a:t>
+            </a:r>
+            <a:endParaRPr lang="en-US" sz="1400" dirty="0"/>
+          </a:p>
+        </p:txBody>
+      </p:sp>
+      <p:sp>
+        <p:nvSpPr>
+          <p:cNvPr id="30" name="Text 28"/>
           <p:cNvSpPr txBox="1"/>
           <p:nvPr/>
         </p:nvSpPr>
         <p:spPr>
           <a:xfrm>
-            <a:off x="3694176" y="3502152"/>
-            <a:ext cx="2103120" cy="301752"/>
-          </a:xfrm>
-          <a:prstGeom prst="rect">
-            <a:avLst/>
-          </a:prstGeom>
-          <a:noFill/>
-          <a:ln/>
-        </p:spPr>
-        <p:txBody>
-          <a:bodyPr wrap="square" lIns="0" tIns="0" rIns="0" bIns="0" rtlCol="0" anchor="t"/>
-          <a:lstStyle/>
-          <a:p>
-            <a:pPr indent="0" marL="0">
-              <a:buNone/>
-            </a:pPr>
-            <a:r>
-              <a:rPr lang="en-US" sz="1050" dirty="0">
-                <a:solidFill>
-                  <a:schemeClr val="accent2"/>
-                </a:solidFill>
-              </a:rPr>
-              <a:t>第2期の純資産倍率。14.4億円で純資産15.9億円を取得</a:t>
-            </a:r>
-            <a:endParaRPr lang="en-US" sz="1050" dirty="0"/>
-          </a:p>
-        </p:txBody>
-      </p:sp>
-      <p:sp>
-        <p:nvSpPr>
-          <p:cNvPr id="16" name="stat 飲食A社の今期営業利益。8.2億円で取得、純資産13.0億円"/>
-          <p:cNvSpPr/>
-          <p:nvPr/>
-        </p:nvSpPr>
-        <p:spPr>
-          <a:xfrm>
-            <a:off x="6227064" y="2011680"/>
-            <a:ext cx="2560320" cy="1901952"/>
-          </a:xfrm>
-          <a:prstGeom prst="roundRect">
-            <a:avLst>
-              <a:gd name="adj" fmla="val 2885"/>
-            </a:avLst>
+            <a:off x="6446520" y="2743200"/>
+            <a:ext cx="1051560" cy="384048"/>
+          </a:xfrm>
+          <a:prstGeom prst="rect">
+            <a:avLst/>
+          </a:prstGeom>
+          <a:noFill/>
+          <a:ln/>
+        </p:spPr>
+        <p:txBody>
+          <a:bodyPr wrap="square" lIns="0" tIns="0" rIns="0" bIns="0" rtlCol="0" anchor="ctr"/>
+          <a:lstStyle/>
+          <a:p>
+            <a:pPr indent="0" marL="0">
+              <a:buNone/>
+            </a:pPr>
+            <a:r>
+              <a:rPr lang="en-US" sz="1100" b="1" dirty="0">
+                <a:solidFill>
+                  <a:schemeClr val="accent3"/>
+                </a:solidFill>
+              </a:rPr>
+              <a:t>購入額</a:t>
+            </a:r>
+            <a:endParaRPr lang="en-US" sz="1100" dirty="0"/>
+          </a:p>
+        </p:txBody>
+      </p:sp>
+      <p:sp>
+        <p:nvSpPr>
+          <p:cNvPr id="31" name="第2期 2020– bar 購入額"/>
+          <p:cNvSpPr/>
+          <p:nvPr/>
+        </p:nvSpPr>
+        <p:spPr>
+          <a:xfrm>
+            <a:off x="7498080" y="2779776"/>
+            <a:ext cx="1446963" cy="310896"/>
+          </a:xfrm>
+          <a:prstGeom prst="rect">
+            <a:avLst/>
           </a:prstGeom>
           <a:solidFill>
-            <a:schemeClr val="bg2"/>
+            <a:srgbClr val="9A8F84"/>
           </a:solidFill>
-          <a:ln w="9525">
+          <a:ln w="12700">
             <a:solidFill>
-              <a:schemeClr val="accent3"/>
+              <a:srgbClr val="9A8F84"/>
             </a:solidFill>
             <a:prstDash val="solid"/>
           </a:ln>
-          <a:effectLst>
-            <a:outerShdw sx="100000" sy="100000" kx="0" ky="0" algn="bl" rotWithShape="0" blurRad="76200" dist="25400" dir="5400000">
-              <a:srgbClr val="6F665F">
-                <a:alpha val="12000"/>
-              </a:srgbClr>
-            </a:outerShdw>
-          </a:effectLst>
-        </p:spPr>
-      </p:sp>
-      <p:sp>
-        <p:nvSpPr>
-          <p:cNvPr id="17" name="Shape 15"/>
-          <p:cNvSpPr/>
-          <p:nvPr/>
-        </p:nvSpPr>
-        <p:spPr>
-          <a:xfrm>
-            <a:off x="6483096" y="2286000"/>
-            <a:ext cx="365760" cy="45720"/>
+        </p:spPr>
+      </p:sp>
+      <p:sp>
+        <p:nvSpPr>
+          <p:cNvPr id="32" name="Text 30"/>
+          <p:cNvSpPr txBox="1"/>
+          <p:nvPr/>
+        </p:nvSpPr>
+        <p:spPr>
+          <a:xfrm>
+            <a:off x="9018195" y="2743200"/>
+            <a:ext cx="822960" cy="384048"/>
+          </a:xfrm>
+          <a:prstGeom prst="rect">
+            <a:avLst/>
+          </a:prstGeom>
+          <a:noFill/>
+          <a:ln/>
+        </p:spPr>
+        <p:txBody>
+          <a:bodyPr wrap="square" lIns="0" tIns="0" rIns="0" bIns="0" rtlCol="0" anchor="ctr"/>
+          <a:lstStyle/>
+          <a:p>
+            <a:pPr indent="0" marL="0">
+              <a:buNone/>
+            </a:pPr>
+            <a:r>
+              <a:rPr lang="en-US" sz="1200" b="1" dirty="0">
+                <a:solidFill>
+                  <a:schemeClr val="bg1"/>
+                </a:solidFill>
+              </a:rPr>
+              <a:t>14.4億</a:t>
+            </a:r>
+            <a:endParaRPr lang="en-US" sz="1200" dirty="0"/>
+          </a:p>
+        </p:txBody>
+      </p:sp>
+      <p:sp>
+        <p:nvSpPr>
+          <p:cNvPr id="33" name="Text 31"/>
+          <p:cNvSpPr txBox="1"/>
+          <p:nvPr/>
+        </p:nvSpPr>
+        <p:spPr>
+          <a:xfrm>
+            <a:off x="6446520" y="3246120"/>
+            <a:ext cx="1051560" cy="384048"/>
+          </a:xfrm>
+          <a:prstGeom prst="rect">
+            <a:avLst/>
+          </a:prstGeom>
+          <a:noFill/>
+          <a:ln/>
+        </p:spPr>
+        <p:txBody>
+          <a:bodyPr wrap="square" lIns="0" tIns="0" rIns="0" bIns="0" rtlCol="0" anchor="ctr"/>
+          <a:lstStyle/>
+          <a:p>
+            <a:pPr indent="0" marL="0">
+              <a:buNone/>
+            </a:pPr>
+            <a:r>
+              <a:rPr lang="en-US" sz="1100" b="1" dirty="0">
+                <a:solidFill>
+                  <a:schemeClr val="accent3"/>
+                </a:solidFill>
+              </a:rPr>
+              <a:t>純資産＋売却</a:t>
+            </a:r>
+            <a:endParaRPr lang="en-US" sz="1100" dirty="0"/>
+          </a:p>
+        </p:txBody>
+      </p:sp>
+      <p:sp>
+        <p:nvSpPr>
+          <p:cNvPr id="34" name="第2期 2020– bar 純資産＋売却"/>
+          <p:cNvSpPr/>
+          <p:nvPr/>
+        </p:nvSpPr>
+        <p:spPr>
+          <a:xfrm>
+            <a:off x="7498080" y="3282696"/>
+            <a:ext cx="1828800" cy="310896"/>
           </a:xfrm>
           <a:prstGeom prst="rect">
             <a:avLst/>
           </a:prstGeom>
           <a:solidFill>
-            <a:schemeClr val="accent1"/>
+            <a:srgbClr val="A78450"/>
           </a:solidFill>
           <a:ln w="12700">
             <a:solidFill>
-              <a:schemeClr val="accent1"/>
+              <a:srgbClr val="A78450"/>
             </a:solidFill>
             <a:prstDash val="solid"/>
           </a:ln>
@@ -14724,14 +14797,14 @@
       </p:sp>
       <p:sp>
         <p:nvSpPr>
-          <p:cNvPr id="18" name="Text 16"/>
+          <p:cNvPr id="35" name="Text 33"/>
           <p:cNvSpPr txBox="1"/>
           <p:nvPr/>
         </p:nvSpPr>
         <p:spPr>
           <a:xfrm>
-            <a:off x="6464808" y="2450592"/>
-            <a:ext cx="2103120" cy="777240"/>
+            <a:off x="9400032" y="3246120"/>
+            <a:ext cx="822960" cy="384048"/>
           </a:xfrm>
           <a:prstGeom prst="rect">
             <a:avLst/>
@@ -14747,143 +14820,231 @@
               <a:buNone/>
             </a:pPr>
             <a:r>
-              <a:rPr lang="en-US" sz="3600" b="1" dirty="0">
+              <a:rPr lang="en-US" sz="1200" b="1" dirty="0">
+                <a:solidFill>
+                  <a:schemeClr val="bg1"/>
+                </a:solidFill>
+              </a:rPr>
+              <a:t>18.2億</a:t>
+            </a:r>
+            <a:endParaRPr lang="en-US" sz="1200" dirty="0"/>
+          </a:p>
+        </p:txBody>
+      </p:sp>
+      <p:sp>
+        <p:nvSpPr>
+          <p:cNvPr id="36" name="Text 34"/>
+          <p:cNvSpPr txBox="1"/>
+          <p:nvPr/>
+        </p:nvSpPr>
+        <p:spPr>
+          <a:xfrm>
+            <a:off x="10104120" y="2651760"/>
+            <a:ext cx="1234440" cy="1051560"/>
+          </a:xfrm>
+          <a:prstGeom prst="rect">
+            <a:avLst/>
+          </a:prstGeom>
+          <a:noFill/>
+          <a:ln/>
+        </p:spPr>
+        <p:txBody>
+          <a:bodyPr wrap="square" lIns="0" tIns="0" rIns="0" bIns="0" rtlCol="0" anchor="ctr"/>
+          <a:lstStyle/>
+          <a:p>
+            <a:pPr algn="r" indent="0" marL="0">
+              <a:buNone/>
+            </a:pPr>
+            <a:r>
+              <a:rPr lang="en-US" sz="2800" b="1" dirty="0">
                 <a:solidFill>
                   <a:schemeClr val="accent1"/>
                 </a:solidFill>
               </a:rPr>
-              <a:t>1.3億</a:t>
-            </a:r>
-            <a:endParaRPr lang="en-US" sz="3600" dirty="0"/>
-          </a:p>
-        </p:txBody>
-      </p:sp>
-      <p:sp>
-        <p:nvSpPr>
-          <p:cNvPr id="19" name="Text 17"/>
-          <p:cNvSpPr txBox="1"/>
-          <p:nvPr/>
-        </p:nvSpPr>
-        <p:spPr>
-          <a:xfrm>
-            <a:off x="6464808" y="3227832"/>
-            <a:ext cx="2103120" cy="274320"/>
-          </a:xfrm>
-          <a:prstGeom prst="rect">
-            <a:avLst/>
-          </a:prstGeom>
-          <a:noFill/>
-          <a:ln/>
-        </p:spPr>
-        <p:txBody>
-          <a:bodyPr wrap="square" lIns="0" tIns="0" rIns="0" bIns="0" rtlCol="0" anchor="t"/>
-          <a:lstStyle/>
-          <a:p>
-            <a:pPr indent="0" marL="0">
-              <a:buNone/>
-            </a:pPr>
-            <a:r>
-              <a:rPr lang="en-US" sz="1300" b="1" dirty="0">
-                <a:solidFill>
-                  <a:schemeClr val="tx1"/>
-                </a:solidFill>
-              </a:rPr>
-              <a:t>円／年</a:t>
+              <a:t>1.3倍</a:t>
             </a:r>
             <a:endParaRPr lang="en-US" sz="1300" dirty="0"/>
           </a:p>
-        </p:txBody>
-      </p:sp>
-      <p:sp>
-        <p:nvSpPr>
-          <p:cNvPr id="20" name="Text 18"/>
-          <p:cNvSpPr txBox="1"/>
-          <p:nvPr/>
-        </p:nvSpPr>
-        <p:spPr>
-          <a:xfrm>
-            <a:off x="6464808" y="3502152"/>
-            <a:ext cx="2103120" cy="301752"/>
-          </a:xfrm>
-          <a:prstGeom prst="rect">
-            <a:avLst/>
-          </a:prstGeom>
-          <a:noFill/>
-          <a:ln/>
-        </p:spPr>
-        <p:txBody>
-          <a:bodyPr wrap="square" lIns="0" tIns="0" rIns="0" bIns="0" rtlCol="0" anchor="t"/>
-          <a:lstStyle/>
-          <a:p>
-            <a:pPr indent="0" marL="0">
-              <a:buNone/>
-            </a:pPr>
-            <a:r>
-              <a:rPr lang="en-US" sz="1050" dirty="0">
-                <a:solidFill>
-                  <a:schemeClr val="accent2"/>
-                </a:solidFill>
-              </a:rPr>
-              <a:t>飲食A社の今期営業利益。8.2億円で取得、純資産13.0億円</a:t>
-            </a:r>
-            <a:endParaRPr lang="en-US" sz="1050" dirty="0"/>
-          </a:p>
-        </p:txBody>
-      </p:sp>
-      <p:sp>
-        <p:nvSpPr>
-          <p:cNvPr id="21" name="stat 飲食B事業の今期営業利益。1,400万円で取得"/>
-          <p:cNvSpPr/>
-          <p:nvPr/>
-        </p:nvSpPr>
-        <p:spPr>
-          <a:xfrm>
-            <a:off x="8997696" y="2011680"/>
-            <a:ext cx="2560320" cy="1901952"/>
-          </a:xfrm>
-          <a:prstGeom prst="roundRect">
-            <a:avLst>
-              <a:gd name="adj" fmla="val 2885"/>
-            </a:avLst>
-          </a:prstGeom>
-          <a:solidFill>
-            <a:schemeClr val="bg2"/>
-          </a:solidFill>
+          <a:p>
+            <a:pPr algn="r" indent="0" marL="0">
+              <a:buNone/>
+            </a:pPr>
+            <a:r>
+              <a:rPr lang="en-US" sz="900" dirty="0">
+                <a:solidFill>
+                  <a:schemeClr val="accent3"/>
+                </a:solidFill>
+              </a:rPr>
+              <a:t>購入額に対する資産</a:t>
+            </a:r>
+            <a:endParaRPr lang="en-US" sz="1300" dirty="0"/>
+          </a:p>
+        </p:txBody>
+      </p:sp>
+      <p:sp>
+        <p:nvSpPr>
+          <p:cNvPr id="37" name="Shape 35"/>
+          <p:cNvSpPr/>
+          <p:nvPr/>
+        </p:nvSpPr>
+        <p:spPr>
+          <a:xfrm>
+            <a:off x="6446520" y="3840480"/>
+            <a:ext cx="4800600" cy="0"/>
+          </a:xfrm>
+          <a:prstGeom prst="line">
+            <a:avLst/>
+          </a:prstGeom>
+          <a:noFill/>
           <a:ln w="9525">
             <a:solidFill>
-              <a:schemeClr val="accent3"/>
+              <a:srgbClr val="4E443C"/>
             </a:solidFill>
             <a:prstDash val="solid"/>
           </a:ln>
-          <a:effectLst>
-            <a:outerShdw sx="100000" sy="100000" kx="0" ky="0" algn="bl" rotWithShape="0" blurRad="76200" dist="25400" dir="5400000">
-              <a:srgbClr val="6F665F">
-                <a:alpha val="12000"/>
-              </a:srgbClr>
-            </a:outerShdw>
-          </a:effectLst>
-        </p:spPr>
-      </p:sp>
-      <p:sp>
-        <p:nvSpPr>
-          <p:cNvPr id="22" name="Shape 20"/>
-          <p:cNvSpPr/>
-          <p:nvPr/>
-        </p:nvSpPr>
-        <p:spPr>
-          <a:xfrm>
-            <a:off x="9253728" y="2286000"/>
-            <a:ext cx="365760" cy="45720"/>
-          </a:xfrm>
-          <a:prstGeom prst="rect">
-            <a:avLst/>
+        </p:spPr>
+      </p:sp>
+      <p:sp>
+        <p:nvSpPr>
+          <p:cNvPr id="38" name="Text 36"/>
+          <p:cNvSpPr txBox="1"/>
+          <p:nvPr/>
+        </p:nvSpPr>
+        <p:spPr>
+          <a:xfrm>
+            <a:off x="6446520" y="3931920"/>
+            <a:ext cx="2377440" cy="274320"/>
+          </a:xfrm>
+          <a:prstGeom prst="rect">
+            <a:avLst/>
+          </a:prstGeom>
+          <a:noFill/>
+          <a:ln/>
+        </p:spPr>
+        <p:txBody>
+          <a:bodyPr wrap="square" lIns="0" tIns="0" rIns="0" bIns="0" rtlCol="0" anchor="t"/>
+          <a:lstStyle/>
+          <a:p>
+            <a:pPr indent="0" marL="0">
+              <a:buNone/>
+            </a:pPr>
+            <a:r>
+              <a:rPr lang="en-US" sz="1100" b="1" dirty="0">
+                <a:solidFill>
+                  <a:schemeClr val="accent3"/>
+                </a:solidFill>
+              </a:rPr>
+              <a:t>単年度の営業利益（2026年予想）</a:t>
+            </a:r>
+            <a:endParaRPr lang="en-US" sz="1100" dirty="0"/>
+          </a:p>
+        </p:txBody>
+      </p:sp>
+      <p:sp>
+        <p:nvSpPr>
+          <p:cNvPr id="39" name="Text 37"/>
+          <p:cNvSpPr txBox="1"/>
+          <p:nvPr/>
+        </p:nvSpPr>
+        <p:spPr>
+          <a:xfrm>
+            <a:off x="6446520" y="4206240"/>
+            <a:ext cx="2468880" cy="640080"/>
+          </a:xfrm>
+          <a:prstGeom prst="rect">
+            <a:avLst/>
+          </a:prstGeom>
+          <a:noFill/>
+          <a:ln/>
+        </p:spPr>
+        <p:txBody>
+          <a:bodyPr wrap="square" lIns="0" tIns="0" rIns="0" bIns="0" rtlCol="0" anchor="ctr"/>
+          <a:lstStyle/>
+          <a:p>
+            <a:pPr indent="0" marL="0">
+              <a:buNone/>
+            </a:pPr>
+            <a:r>
+              <a:rPr lang="en-US" sz="3000" b="1" dirty="0">
+                <a:solidFill>
+                  <a:schemeClr val="accent4"/>
+                </a:solidFill>
+              </a:rPr>
+              <a:t>2.4</a:t>
+            </a:r>
+            <a:pPr indent="0" marL="0">
+              <a:buNone/>
+            </a:pPr>
+            <a:r>
+              <a:rPr lang="en-US" sz="1200" b="1" dirty="0">
+                <a:solidFill>
+                  <a:schemeClr val="accent3"/>
+                </a:solidFill>
+              </a:rPr>
+              <a:t> 億円／年</a:t>
+            </a:r>
+            <a:endParaRPr lang="en-US" sz="1300" dirty="0"/>
+          </a:p>
+        </p:txBody>
+      </p:sp>
+      <p:sp>
+        <p:nvSpPr>
+          <p:cNvPr id="40" name="Text 38"/>
+          <p:cNvSpPr txBox="1"/>
+          <p:nvPr/>
+        </p:nvSpPr>
+        <p:spPr>
+          <a:xfrm>
+            <a:off x="6446520" y="4846320"/>
+            <a:ext cx="2377440" cy="457200"/>
+          </a:xfrm>
+          <a:prstGeom prst="rect">
+            <a:avLst/>
+          </a:prstGeom>
+          <a:noFill/>
+          <a:ln/>
+        </p:spPr>
+        <p:txBody>
+          <a:bodyPr wrap="square" lIns="0" tIns="0" rIns="0" bIns="0" rtlCol="0" anchor="t"/>
+          <a:lstStyle/>
+          <a:p>
+            <a:pPr indent="0" marL="0">
+              <a:buNone/>
+            </a:pPr>
+            <a:r>
+              <a:rPr lang="en-US" sz="950" dirty="0">
+                <a:solidFill>
+                  <a:schemeClr val="accent3"/>
+                </a:solidFill>
+              </a:rPr>
+              <a:t>M&amp;Aで取得したグループ会社の合計</a:t>
+            </a:r>
+            <a:endParaRPr lang="en-US" sz="950" dirty="0"/>
+          </a:p>
+        </p:txBody>
+      </p:sp>
+      <p:sp>
+        <p:nvSpPr>
+          <p:cNvPr id="41" name="第2期 2020– deal 1"/>
+          <p:cNvSpPr/>
+          <p:nvPr/>
+        </p:nvSpPr>
+        <p:spPr>
+          <a:xfrm>
+            <a:off x="8961120" y="3977640"/>
+            <a:ext cx="2286000" cy="594360"/>
+          </a:xfrm>
+          <a:prstGeom prst="roundRect">
+            <a:avLst>
+              <a:gd name="adj" fmla="val 7692"/>
+            </a:avLst>
           </a:prstGeom>
           <a:solidFill>
-            <a:schemeClr val="accent1"/>
+            <a:srgbClr val="3A322C"/>
           </a:solidFill>
           <a:ln w="12700">
             <a:solidFill>
-              <a:schemeClr val="accent1"/>
+              <a:srgbClr val="4E443C"/>
             </a:solidFill>
             <a:prstDash val="solid"/>
           </a:ln>
@@ -14891,14 +15052,14 @@
       </p:sp>
       <p:sp>
         <p:nvSpPr>
-          <p:cNvPr id="23" name="Text 21"/>
+          <p:cNvPr id="42" name="Text 40"/>
           <p:cNvSpPr txBox="1"/>
           <p:nvPr/>
         </p:nvSpPr>
         <p:spPr>
           <a:xfrm>
-            <a:off x="9235440" y="2450592"/>
-            <a:ext cx="2103120" cy="777240"/>
+            <a:off x="9052560" y="3977640"/>
+            <a:ext cx="2148840" cy="594360"/>
           </a:xfrm>
           <a:prstGeom prst="rect">
             <a:avLst/>
@@ -14914,149 +15075,68 @@
               <a:buNone/>
             </a:pPr>
             <a:r>
-              <a:rPr lang="en-US" sz="3600" b="1" dirty="0">
-                <a:solidFill>
-                  <a:schemeClr val="accent1"/>
-                </a:solidFill>
-              </a:rPr>
-              <a:t>8,000万</a:t>
-            </a:r>
-            <a:endParaRPr lang="en-US" sz="3600" dirty="0"/>
-          </a:p>
-        </p:txBody>
-      </p:sp>
-      <p:sp>
-        <p:nvSpPr>
-          <p:cNvPr id="24" name="Text 22"/>
-          <p:cNvSpPr txBox="1"/>
-          <p:nvPr/>
-        </p:nvSpPr>
-        <p:spPr>
-          <a:xfrm>
-            <a:off x="9235440" y="3227832"/>
-            <a:ext cx="2103120" cy="274320"/>
-          </a:xfrm>
-          <a:prstGeom prst="rect">
-            <a:avLst/>
-          </a:prstGeom>
-          <a:noFill/>
-          <a:ln/>
-        </p:spPr>
-        <p:txBody>
-          <a:bodyPr wrap="square" lIns="0" tIns="0" rIns="0" bIns="0" rtlCol="0" anchor="t"/>
-          <a:lstStyle/>
-          <a:p>
-            <a:pPr indent="0" marL="0">
-              <a:buNone/>
-            </a:pPr>
-            <a:r>
-              <a:rPr lang="en-US" sz="1300" b="1" dirty="0">
-                <a:solidFill>
-                  <a:schemeClr val="tx1"/>
-                </a:solidFill>
-              </a:rPr>
-              <a:t>円／年</a:t>
+              <a:rPr lang="en-US" sz="1050" b="1" dirty="0">
+                <a:solidFill>
+                  <a:schemeClr val="bg1"/>
+                </a:solidFill>
+              </a:rPr>
+              <a:t>飲食A社</a:t>
             </a:r>
             <a:endParaRPr lang="en-US" sz="1300" dirty="0"/>
           </a:p>
-        </p:txBody>
-      </p:sp>
-      <p:sp>
-        <p:nvSpPr>
-          <p:cNvPr id="25" name="Text 23"/>
-          <p:cNvSpPr txBox="1"/>
-          <p:nvPr/>
-        </p:nvSpPr>
-        <p:spPr>
-          <a:xfrm>
-            <a:off x="9235440" y="3502152"/>
-            <a:ext cx="2103120" cy="301752"/>
-          </a:xfrm>
-          <a:prstGeom prst="rect">
-            <a:avLst/>
-          </a:prstGeom>
-          <a:noFill/>
-          <a:ln/>
-        </p:spPr>
-        <p:txBody>
-          <a:bodyPr wrap="square" lIns="0" tIns="0" rIns="0" bIns="0" rtlCol="0" anchor="t"/>
-          <a:lstStyle/>
-          <a:p>
-            <a:pPr indent="0" marL="0">
-              <a:buNone/>
-            </a:pPr>
-            <a:r>
-              <a:rPr lang="en-US" sz="1050" dirty="0">
-                <a:solidFill>
-                  <a:schemeClr val="accent2"/>
-                </a:solidFill>
-              </a:rPr>
-              <a:t>飲食B事業の今期営業利益。1,400万円で取得</a:t>
-            </a:r>
-            <a:endParaRPr lang="en-US" sz="1050" dirty="0"/>
-          </a:p>
-        </p:txBody>
-      </p:sp>
-      <p:graphicFrame>
-        <p:nvGraphicFramePr>
-          <p:cNvPr id="26" name="invest vs return chart" descr=""/>
-          <p:cNvGraphicFramePr/>
-          <p:nvPr/>
-        </p:nvGraphicFramePr>
-        <p:xfrm>
-          <a:off x="685800" y="4023360"/>
-          <a:ext cx="6400800" cy="2011680"/>
-        </p:xfrm>
-        <a:graphic xmlns:a="http://schemas.openxmlformats.org/drawingml/2006/main">
-          <a:graphicData uri="http://schemas.openxmlformats.org/drawingml/2006/chart">
-            <c:chart xmlns:c="http://schemas.openxmlformats.org/drawingml/2006/chart" r:id="rId1"/>
-          </a:graphicData>
-        </a:graphic>
-      </p:graphicFrame>
-      <p:sp>
-        <p:nvSpPr>
-          <p:cNvPr id="27" name="phase1 note"/>
-          <p:cNvSpPr/>
-          <p:nvPr/>
-        </p:nvSpPr>
-        <p:spPr>
-          <a:xfrm>
-            <a:off x="7315200" y="4041648"/>
-            <a:ext cx="4187952" cy="932688"/>
+          <a:p>
+            <a:pPr indent="0" marL="0">
+              <a:buNone/>
+            </a:pPr>
+            <a:r>
+              <a:rPr lang="en-US" sz="900" dirty="0">
+                <a:solidFill>
+                  <a:schemeClr val="accent3"/>
+                </a:solidFill>
+              </a:rPr>
+              <a:t>8.2億円 → 純資産13.0億＋営業利益1.3億／年</a:t>
+            </a:r>
+            <a:endParaRPr lang="en-US" sz="1300" dirty="0"/>
+          </a:p>
+        </p:txBody>
+      </p:sp>
+      <p:sp>
+        <p:nvSpPr>
+          <p:cNvPr id="43" name="第2期 2020– deal 2"/>
+          <p:cNvSpPr/>
+          <p:nvPr/>
+        </p:nvSpPr>
+        <p:spPr>
+          <a:xfrm>
+            <a:off x="8961120" y="4663440"/>
+            <a:ext cx="2286000" cy="594360"/>
           </a:xfrm>
           <a:prstGeom prst="roundRect">
             <a:avLst>
-              <a:gd name="adj" fmla="val 5882"/>
+              <a:gd name="adj" fmla="val 7692"/>
             </a:avLst>
           </a:prstGeom>
           <a:solidFill>
-            <a:srgbClr val="FFFFFF"/>
+            <a:srgbClr val="3A322C"/>
           </a:solidFill>
-          <a:ln w="9525">
+          <a:ln w="12700">
             <a:solidFill>
-              <a:schemeClr val="accent3"/>
+              <a:srgbClr val="4E443C"/>
             </a:solidFill>
             <a:prstDash val="solid"/>
           </a:ln>
-          <a:effectLst>
-            <a:outerShdw sx="100000" sy="100000" kx="0" ky="0" algn="bl" rotWithShape="0" blurRad="76200" dist="25400" dir="5400000">
-              <a:srgbClr val="6F665F">
-                <a:alpha val="12000"/>
-              </a:srgbClr>
-            </a:outerShdw>
-          </a:effectLst>
-        </p:spPr>
-      </p:sp>
-      <p:sp>
-        <p:nvSpPr>
-          <p:cNvPr id="28" name="Text 25"/>
+        </p:spPr>
+      </p:sp>
+      <p:sp>
+        <p:nvSpPr>
+          <p:cNvPr id="44" name="Text 42"/>
           <p:cNvSpPr txBox="1"/>
           <p:nvPr/>
         </p:nvSpPr>
         <p:spPr>
           <a:xfrm>
-            <a:off x="7498080" y="4041648"/>
-            <a:ext cx="3840480" cy="932688"/>
+            <a:off x="9052560" y="4663440"/>
+            <a:ext cx="2148840" cy="594360"/>
           </a:xfrm>
           <a:prstGeom prst="rect">
             <a:avLst/>
@@ -15072,75 +15152,41 @@
               <a:buNone/>
             </a:pPr>
             <a:r>
-              <a:rPr lang="en-US" sz="1200" b="1" dirty="0">
-                <a:solidFill>
-                  <a:schemeClr val="accent2"/>
-                </a:solidFill>
-              </a:rPr>
-              <a:t>第1期 2011–19：数で獲りにいった</a:t>
-            </a:r>
-            <a:endParaRPr lang="en-US" sz="1200" dirty="0"/>
-          </a:p>
-          <a:p>
-            <a:pPr indent="0" marL="0">
-              <a:buNone/>
-            </a:pPr>
-            <a:r>
-              <a:rPr lang="en-US" sz="1050" dirty="0">
-                <a:solidFill>
-                  <a:schemeClr val="tx1"/>
-                </a:solidFill>
-              </a:rPr>
-              <a:t>売上の0.25倍で買い、保有中の営業利益7.6億＋売却5.3億＋純資産2.0億で回収</a:t>
-            </a:r>
-            <a:endParaRPr lang="en-US" sz="1200" dirty="0"/>
-          </a:p>
-        </p:txBody>
-      </p:sp>
-      <p:sp>
-        <p:nvSpPr>
-          <p:cNvPr id="29" name="phase2 note"/>
-          <p:cNvSpPr/>
-          <p:nvPr/>
-        </p:nvSpPr>
-        <p:spPr>
-          <a:xfrm>
-            <a:off x="7315200" y="5084064"/>
-            <a:ext cx="4187952" cy="932688"/>
-          </a:xfrm>
-          <a:prstGeom prst="roundRect">
-            <a:avLst>
-              <a:gd name="adj" fmla="val 5882"/>
-            </a:avLst>
-          </a:prstGeom>
-          <a:solidFill>
-            <a:schemeClr val="bg2"/>
-          </a:solidFill>
-          <a:ln w="9525">
-            <a:solidFill>
-              <a:schemeClr val="accent3"/>
-            </a:solidFill>
-            <a:prstDash val="solid"/>
-          </a:ln>
-          <a:effectLst>
-            <a:outerShdw sx="100000" sy="100000" kx="0" ky="0" algn="bl" rotWithShape="0" blurRad="76200" dist="25400" dir="5400000">
-              <a:srgbClr val="6F665F">
-                <a:alpha val="12000"/>
-              </a:srgbClr>
-            </a:outerShdw>
-          </a:effectLst>
-        </p:spPr>
-      </p:sp>
-      <p:sp>
-        <p:nvSpPr>
-          <p:cNvPr id="30" name="Text 27"/>
+              <a:rPr lang="en-US" sz="1050" b="1" dirty="0">
+                <a:solidFill>
+                  <a:schemeClr val="bg1"/>
+                </a:solidFill>
+              </a:rPr>
+              <a:t>飲食B事業</a:t>
+            </a:r>
+            <a:endParaRPr lang="en-US" sz="1300" dirty="0"/>
+          </a:p>
+          <a:p>
+            <a:pPr indent="0" marL="0">
+              <a:buNone/>
+            </a:pPr>
+            <a:r>
+              <a:rPr lang="en-US" sz="900" dirty="0">
+                <a:solidFill>
+                  <a:schemeClr val="accent3"/>
+                </a:solidFill>
+              </a:rPr>
+              <a:t>1,400万円 → 純資産7,000万＋営業利益8,000万／年</a:t>
+            </a:r>
+            <a:endParaRPr lang="en-US" sz="1300" dirty="0"/>
+          </a:p>
+        </p:txBody>
+      </p:sp>
+      <p:sp>
+        <p:nvSpPr>
+          <p:cNvPr id="45" name="Text 43"/>
           <p:cNvSpPr txBox="1"/>
           <p:nvPr/>
         </p:nvSpPr>
         <p:spPr>
           <a:xfrm>
-            <a:off x="7498080" y="5084064"/>
-            <a:ext cx="3840480" cy="932688"/>
+            <a:off x="6446520" y="5440680"/>
+            <a:ext cx="4800600" cy="502920"/>
           </a:xfrm>
           <a:prstGeom prst="rect">
             <a:avLst/>
@@ -15156,34 +15202,20 @@
               <a:buNone/>
             </a:pPr>
             <a:r>
-              <a:rPr lang="en-US" sz="1200" b="1" dirty="0">
-                <a:solidFill>
-                  <a:schemeClr val="accent1"/>
-                </a:solidFill>
-              </a:rPr>
-              <a:t>第2期 2020–：純資産より安く買う</a:t>
-            </a:r>
-            <a:endParaRPr lang="en-US" sz="1200" dirty="0"/>
-          </a:p>
-          <a:p>
-            <a:pPr indent="0" marL="0">
-              <a:buNone/>
-            </a:pPr>
-            <a:r>
-              <a:rPr lang="en-US" sz="1050" dirty="0">
-                <a:solidFill>
-                  <a:schemeClr val="tx1"/>
-                </a:solidFill>
-              </a:rPr>
-              <a:t>主要2件だけで今期営業利益2.1億円。買収額8.3億円を約4年で回収し、純資産は買値以上</a:t>
-            </a:r>
-            <a:endParaRPr lang="en-US" sz="1200" dirty="0"/>
-          </a:p>
-        </p:txBody>
-      </p:sp>
-      <p:sp>
-        <p:nvSpPr>
-          <p:cNvPr id="31" name="Text 28"/>
+              <a:rPr lang="en-US" sz="1150" b="1" dirty="0">
+                <a:solidFill>
+                  <a:schemeClr val="accent4"/>
+                </a:solidFill>
+              </a:rPr>
+              <a:t>買った時点で資産が買値を上回り、利益は毎年積み上がる</a:t>
+            </a:r>
+            <a:endParaRPr lang="en-US" sz="1150" dirty="0"/>
+          </a:p>
+        </p:txBody>
+      </p:sp>
+      <p:sp>
+        <p:nvSpPr>
+          <p:cNvPr id="46" name="Text 44"/>
           <p:cNvSpPr txBox="1"/>
           <p:nvPr/>
         </p:nvSpPr>
@@ -15211,7 +15243,7 @@
                   <a:schemeClr val="accent5"/>
                 </a:solidFill>
               </a:rPr>
-              <a:t>単位：億円。第1期の営業利益は保有期間中の累計。グラフの第2期の利益はM&amp;Aで取得したグループ会社全体の2026年予想。出典：中野邦人 M&amp;A勝敗一覧表、グループ売上管理表</a:t>
+              <a:t>第2期の純資産＋売却は、売却済み案件を売却額に置き換えて算出（あどばる株式の売却は含めない）。出典：中野邦人 M&amp;A勝敗一覧表</a:t>
             </a:r>
             <a:endParaRPr lang="en-US" sz="900" dirty="0"/>
           </a:p>

</xml_diff>